<commit_message>
feat(fn): redesign BC-ResNet architecture diagrams strictly matching MT style with native editable PPTX
</commit_message>
<xml_diff>
--- a/FN/results/BC_ResNet_Architectures.pptx
+++ b/FN/results/BC_ResNet_Architectures.pptx
@@ -3097,8 +3097,8 @@
         </p:nvSpPr>
         <p:spPr>
           <a:xfrm>
-            <a:off x="731520" y="365760"/>
-            <a:ext cx="10728655" cy="731520"/>
+            <a:off x="548640" y="320040"/>
+            <a:ext cx="11094415" cy="822960"/>
           </a:xfrm>
           <a:prstGeom prst="rect">
             <a:avLst/>
@@ -3119,12 +3119,12 @@
               </a:defRPr>
             </a:pPr>
             <a:r>
-              <a:t>Figure: Qualcomm SOTA BC-ResNet Architecture (Keyword Spotting)</a:t>
+              <a:t>Qualcomm SOTA Broadcasted Residual Network (BC-ResNet) Architecture</a:t>
             </a:r>
           </a:p>
           <a:p>
             <a:pPr>
-              <a:defRPr sz="1200">
+              <a:defRPr sz="1100">
                 <a:solidFill>
                   <a:srgbClr val="475569"/>
                 </a:solidFill>
@@ -3144,8 +3144,8 @@
         </p:nvSpPr>
         <p:spPr>
           <a:xfrm>
-            <a:off x="731520" y="1371600"/>
-            <a:ext cx="1325880" cy="4206240"/>
+            <a:off x="548640" y="1645920"/>
+            <a:ext cx="1280160" cy="1188720"/>
           </a:xfrm>
           <a:prstGeom prst="roundRect">
             <a:avLst/>
@@ -3153,7 +3153,7 @@
           <a:solidFill>
             <a:srgbClr val="F5A623"/>
           </a:solidFill>
-          <a:ln w="19050">
+          <a:ln w="15240">
             <a:solidFill>
               <a:srgbClr val="1A252C"/>
             </a:solidFill>
@@ -3174,90 +3174,26 @@
           </a:fontRef>
         </p:style>
         <p:txBody>
-          <a:bodyPr rtlCol="0" anchor="ctr" wrap="square" tIns="182880" lIns="73152" rIns="73152"/>
+          <a:bodyPr rtlCol="0" anchor="ctr" wrap="square" tIns="36576" bIns="36576" lIns="36576" rIns="36576"/>
           <a:lstStyle/>
           <a:p>
             <a:pPr algn="ctr">
-              <a:defRPr b="1" sz="1200">
+              <a:defRPr sz="900" b="1">
                 <a:solidFill>
                   <a:srgbClr val="000000"/>
                 </a:solidFill>
               </a:defRPr>
             </a:pPr>
             <a:r>
-              <a:t>Input Signal</a:t>
-            </a:r>
-          </a:p>
-          <a:p>
-            <a:pPr algn="ctr">
-              <a:defRPr sz="800">
-                <a:solidFill>
-                  <a:srgbClr val="000000"/>
-                </a:solidFill>
-              </a:defRPr>
-            </a:pPr>
-            <a:r>
-              <a:t>─────────</a:t>
-            </a:r>
-          </a:p>
-          <a:p>
-            <a:pPr algn="ctr">
-              <a:defRPr sz="950" b="0">
-                <a:solidFill>
-                  <a:srgbClr val="000000"/>
-                </a:solidFill>
-              </a:defRPr>
-            </a:pPr>
+              <a:t>Input Audio</a:t>
+            </a:r>
+            <a:br/>
             <a:r>
               <a:t>Mel-Spectrogram</a:t>
             </a:r>
-          </a:p>
-          <a:p>
-            <a:pPr algn="ctr">
-              <a:defRPr sz="950" b="0">
-                <a:solidFill>
-                  <a:srgbClr val="000000"/>
-                </a:solidFill>
-              </a:defRPr>
-            </a:pPr>
-            <a:r>
-              <a:t>1 × 128 × 63</a:t>
-            </a:r>
-          </a:p>
-          <a:p>
-            <a:pPr algn="ctr">
-              <a:defRPr sz="950" b="0">
-                <a:solidFill>
-                  <a:srgbClr val="000000"/>
-                </a:solidFill>
-              </a:defRPr>
-            </a:pPr>
-            <a:r>
-              <a:t>(2.0s @ 16kHz)</a:t>
-            </a:r>
-          </a:p>
-          <a:p>
-            <a:pPr algn="ctr">
-              <a:defRPr sz="950" b="0">
-                <a:solidFill>
-                  <a:srgbClr val="000000"/>
-                </a:solidFill>
-              </a:defRPr>
-            </a:pPr>
-            <a:r>
-              <a:t>128 Mel Bins</a:t>
-            </a:r>
-          </a:p>
-          <a:p>
-            <a:pPr algn="ctr">
-              <a:defRPr sz="950" b="0">
-                <a:solidFill>
-                  <a:srgbClr val="000000"/>
-                </a:solidFill>
-              </a:defRPr>
-            </a:pPr>
-            <a:r>
-              <a:t>63 Time Frames</a:t>
+            <a:br/>
+            <a:r>
+              <a:t>(1, 128, 63)</a:t>
             </a:r>
           </a:p>
         </p:txBody>
@@ -3270,8 +3206,8 @@
         </p:nvSpPr>
         <p:spPr>
           <a:xfrm>
-            <a:off x="2286000" y="1371600"/>
-            <a:ext cx="1325880" cy="4206240"/>
+            <a:off x="548640" y="3474720"/>
+            <a:ext cx="1280160" cy="1188720"/>
           </a:xfrm>
           <a:prstGeom prst="roundRect">
             <a:avLst/>
@@ -3279,7 +3215,7 @@
           <a:solidFill>
             <a:srgbClr val="27AE60"/>
           </a:solidFill>
-          <a:ln w="19050">
+          <a:ln w="15240">
             <a:solidFill>
               <a:srgbClr val="1A252C"/>
             </a:solidFill>
@@ -3300,11 +3236,11 @@
           </a:fontRef>
         </p:style>
         <p:txBody>
-          <a:bodyPr rtlCol="0" anchor="ctr" wrap="square" tIns="182880" lIns="73152" rIns="73152"/>
+          <a:bodyPr rtlCol="0" anchor="ctr" wrap="square" tIns="36576" bIns="36576" lIns="36576" rIns="36576"/>
           <a:lstStyle/>
           <a:p>
             <a:pPr algn="ctr">
-              <a:defRPr b="1" sz="1200">
+              <a:defRPr sz="850" b="1">
                 <a:solidFill>
                   <a:srgbClr val="FFFFFF"/>
                 </a:solidFill>
@@ -3313,89 +3249,13 @@
             <a:r>
               <a:t>Stem Layer</a:t>
             </a:r>
-          </a:p>
-          <a:p>
-            <a:pPr algn="ctr">
-              <a:defRPr sz="800">
-                <a:solidFill>
-                  <a:srgbClr val="FFFFFF"/>
-                </a:solidFill>
-              </a:defRPr>
-            </a:pPr>
-            <a:r>
-              <a:t>─────────</a:t>
-            </a:r>
-          </a:p>
-          <a:p>
-            <a:pPr algn="ctr">
-              <a:defRPr sz="950" b="0">
-                <a:solidFill>
-                  <a:srgbClr val="FFFFFF"/>
-                </a:solidFill>
-              </a:defRPr>
-            </a:pPr>
-            <a:r>
-              <a:t>Conv2d (3×3)</a:t>
-            </a:r>
-          </a:p>
-          <a:p>
-            <a:pPr algn="ctr">
-              <a:defRPr sz="950" b="0">
-                <a:solidFill>
-                  <a:srgbClr val="FFFFFF"/>
-                </a:solidFill>
-              </a:defRPr>
-            </a:pPr>
-            <a:r>
-              <a:t>Stride = 1</a:t>
-            </a:r>
-          </a:p>
-          <a:p>
-            <a:pPr algn="ctr">
-              <a:defRPr sz="950" b="0">
-                <a:solidFill>
-                  <a:srgbClr val="FFFFFF"/>
-                </a:solidFill>
-              </a:defRPr>
-            </a:pPr>
-            <a:r>
-              <a:t>BatchNorm2d</a:t>
-            </a:r>
-          </a:p>
-          <a:p>
-            <a:pPr algn="ctr">
-              <a:defRPr sz="950" b="0">
-                <a:solidFill>
-                  <a:srgbClr val="FFFFFF"/>
-                </a:solidFill>
-              </a:defRPr>
-            </a:pPr>
-            <a:r>
-              <a:t>ReLU Activation</a:t>
-            </a:r>
-          </a:p>
-          <a:p>
-            <a:pPr algn="ctr">
-              <a:defRPr sz="950" b="1">
-                <a:solidFill>
-                  <a:srgbClr val="FFFFFF"/>
-                </a:solidFill>
-              </a:defRPr>
-            </a:pPr>
-            <a:r>
-              <a:t>Out: 32×128×63</a:t>
-            </a:r>
-          </a:p>
-          <a:p>
-            <a:pPr algn="ctr">
-              <a:defRPr sz="950" b="1">
-                <a:solidFill>
-                  <a:srgbClr val="FFFFFF"/>
-                </a:solidFill>
-              </a:defRPr>
-            </a:pPr>
-            <a:r>
-              <a:t>Params: 320</a:t>
+            <a:br/>
+            <a:r>
+              <a:t>Conv2d (3x3, c=32)</a:t>
+            </a:r>
+            <a:br/>
+            <a:r>
+              <a:t>+ BN + ReLU</a:t>
             </a:r>
           </a:p>
         </p:txBody>
@@ -3408,18 +3268,18 @@
         </p:nvSpPr>
         <p:spPr>
           <a:xfrm>
-            <a:off x="3840480" y="1371600"/>
-            <a:ext cx="1417320" cy="4206240"/>
+            <a:off x="2103120" y="1554480"/>
+            <a:ext cx="1645920" cy="3931920"/>
           </a:xfrm>
           <a:prstGeom prst="roundRect">
             <a:avLst/>
           </a:prstGeom>
           <a:solidFill>
-            <a:srgbClr val="4A90E2"/>
+            <a:srgbClr val="FFFBF5"/>
           </a:solidFill>
           <a:ln w="19050">
             <a:solidFill>
-              <a:srgbClr val="1A252C"/>
+              <a:srgbClr val="E65100"/>
             </a:solidFill>
           </a:ln>
         </p:spPr>
@@ -3438,103 +3298,10 @@
           </a:fontRef>
         </p:style>
         <p:txBody>
-          <a:bodyPr rtlCol="0" anchor="ctr" wrap="square" tIns="182880" lIns="73152" rIns="73152"/>
-          <a:lstStyle/>
-          <a:p>
-            <a:pPr algn="ctr">
-              <a:defRPr b="1" sz="1200">
-                <a:solidFill>
-                  <a:srgbClr val="FFFFFF"/>
-                </a:solidFill>
-              </a:defRPr>
-            </a:pPr>
-            <a:r>
-              <a:t>Stage 1</a:t>
-            </a:r>
-          </a:p>
-          <a:p>
-            <a:pPr algn="ctr">
-              <a:defRPr sz="800">
-                <a:solidFill>
-                  <a:srgbClr val="FFFFFF"/>
-                </a:solidFill>
-              </a:defRPr>
-            </a:pPr>
-            <a:r>
-              <a:t>─────────</a:t>
-            </a:r>
-          </a:p>
-          <a:p>
-            <a:pPr algn="ctr">
-              <a:defRPr sz="950" b="0">
-                <a:solidFill>
-                  <a:srgbClr val="FFFFFF"/>
-                </a:solidFill>
-              </a:defRPr>
-            </a:pPr>
-            <a:r>
-              <a:t>BCResBlock (32)</a:t>
-            </a:r>
-          </a:p>
-          <a:p>
-            <a:pPr algn="ctr">
-              <a:defRPr sz="950" b="0">
-                <a:solidFill>
-                  <a:srgbClr val="FFFFFF"/>
-                </a:solidFill>
-              </a:defRPr>
-            </a:pPr>
-            <a:r>
-              <a:t>FreqConv (3×1)</a:t>
-            </a:r>
-          </a:p>
-          <a:p>
-            <a:pPr algn="ctr">
-              <a:defRPr sz="950" b="0">
-                <a:solidFill>
-                  <a:srgbClr val="FFFFFF"/>
-                </a:solidFill>
-              </a:defRPr>
-            </a:pPr>
-            <a:r>
-              <a:t>Pointwise (1×1)</a:t>
-            </a:r>
-          </a:p>
-          <a:p>
-            <a:pPr algn="ctr">
-              <a:defRPr sz="950" b="0">
-                <a:solidFill>
-                  <a:srgbClr val="FFFFFF"/>
-                </a:solidFill>
-              </a:defRPr>
-            </a:pPr>
-            <a:r>
-              <a:t>Broadcast Attn</a:t>
-            </a:r>
-          </a:p>
-          <a:p>
-            <a:pPr algn="ctr">
-              <a:defRPr sz="950" b="0">
-                <a:solidFill>
-                  <a:srgbClr val="FFFFFF"/>
-                </a:solidFill>
-              </a:defRPr>
-            </a:pPr>
-            <a:r>
-              <a:t>Identity Shortcut</a:t>
-            </a:r>
-          </a:p>
-          <a:p>
-            <a:pPr algn="ctr">
-              <a:defRPr sz="950" b="1">
-                <a:solidFill>
-                  <a:srgbClr val="FFFFFF"/>
-                </a:solidFill>
-              </a:defRPr>
-            </a:pPr>
-            <a:r>
-              <a:t>Out: 32×128×63</a:t>
-            </a:r>
+          <a:bodyPr rtlCol="0" anchor="ctr"/>
+          <a:lstStyle/>
+          <a:p>
+            <a:pPr algn="ctr"/>
           </a:p>
         </p:txBody>
       </p:sp>
@@ -3546,18 +3313,18 @@
         </p:nvSpPr>
         <p:spPr>
           <a:xfrm>
-            <a:off x="5486400" y="1371600"/>
-            <a:ext cx="1417320" cy="4206240"/>
+            <a:off x="2194560" y="1408176"/>
+            <a:ext cx="1463040" cy="292608"/>
           </a:xfrm>
           <a:prstGeom prst="roundRect">
             <a:avLst/>
           </a:prstGeom>
           <a:solidFill>
-            <a:srgbClr val="4A90E2"/>
-          </a:solidFill>
-          <a:ln w="19050">
+            <a:srgbClr val="FFE0B2"/>
+          </a:solidFill>
+          <a:ln w="12700">
             <a:solidFill>
-              <a:srgbClr val="1A252C"/>
+              <a:srgbClr val="E65100"/>
             </a:solidFill>
           </a:ln>
         </p:spPr>
@@ -3576,102 +3343,18 @@
           </a:fontRef>
         </p:style>
         <p:txBody>
-          <a:bodyPr rtlCol="0" anchor="ctr" wrap="square" tIns="182880" lIns="73152" rIns="73152"/>
+          <a:bodyPr rtlCol="0" anchor="ctr"/>
           <a:lstStyle/>
           <a:p>
             <a:pPr algn="ctr">
-              <a:defRPr b="1" sz="1200">
-                <a:solidFill>
-                  <a:srgbClr val="FFFFFF"/>
+              <a:defRPr sz="850" b="1">
+                <a:solidFill>
+                  <a:srgbClr val="BF360C"/>
                 </a:solidFill>
               </a:defRPr>
             </a:pPr>
             <a:r>
-              <a:t>Stage 2</a:t>
-            </a:r>
-          </a:p>
-          <a:p>
-            <a:pPr algn="ctr">
-              <a:defRPr sz="800">
-                <a:solidFill>
-                  <a:srgbClr val="FFFFFF"/>
-                </a:solidFill>
-              </a:defRPr>
-            </a:pPr>
-            <a:r>
-              <a:t>─────────</a:t>
-            </a:r>
-          </a:p>
-          <a:p>
-            <a:pPr algn="ctr">
-              <a:defRPr sz="950" b="0">
-                <a:solidFill>
-                  <a:srgbClr val="FFFFFF"/>
-                </a:solidFill>
-              </a:defRPr>
-            </a:pPr>
-            <a:r>
-              <a:t>BCResBlock (64)</a:t>
-            </a:r>
-          </a:p>
-          <a:p>
-            <a:pPr algn="ctr">
-              <a:defRPr sz="950" b="0">
-                <a:solidFill>
-                  <a:srgbClr val="FFFFFF"/>
-                </a:solidFill>
-              </a:defRPr>
-            </a:pPr>
-            <a:r>
-              <a:t>FreqConv (3×1)</a:t>
-            </a:r>
-          </a:p>
-          <a:p>
-            <a:pPr algn="ctr">
-              <a:defRPr sz="950" b="0">
-                <a:solidFill>
-                  <a:srgbClr val="FFFFFF"/>
-                </a:solidFill>
-              </a:defRPr>
-            </a:pPr>
-            <a:r>
-              <a:t>Stride = 2</a:t>
-            </a:r>
-          </a:p>
-          <a:p>
-            <a:pPr algn="ctr">
-              <a:defRPr sz="950" b="0">
-                <a:solidFill>
-                  <a:srgbClr val="FFFFFF"/>
-                </a:solidFill>
-              </a:defRPr>
-            </a:pPr>
-            <a:r>
-              <a:t>Broadcast Attn</a:t>
-            </a:r>
-          </a:p>
-          <a:p>
-            <a:pPr algn="ctr">
-              <a:defRPr sz="950" b="0">
-                <a:solidFill>
-                  <a:srgbClr val="FFFFFF"/>
-                </a:solidFill>
-              </a:defRPr>
-            </a:pPr>
-            <a:r>
-              <a:t>Proj Shortcut</a:t>
-            </a:r>
-          </a:p>
-          <a:p>
-            <a:pPr algn="ctr">
-              <a:defRPr sz="950" b="1">
-                <a:solidFill>
-                  <a:srgbClr val="FFFFFF"/>
-                </a:solidFill>
-              </a:defRPr>
-            </a:pPr>
-            <a:r>
-              <a:t>Out: 64×64×32</a:t>
+              <a:t>BC-ResBlock 1 (s=1)</a:t>
             </a:r>
           </a:p>
         </p:txBody>
@@ -3684,8 +3367,8 @@
         </p:nvSpPr>
         <p:spPr>
           <a:xfrm>
-            <a:off x="7132320" y="1371600"/>
-            <a:ext cx="1417320" cy="4206240"/>
+            <a:off x="2240280" y="1828800"/>
+            <a:ext cx="1371600" cy="685800"/>
           </a:xfrm>
           <a:prstGeom prst="roundRect">
             <a:avLst/>
@@ -3693,7 +3376,7 @@
           <a:solidFill>
             <a:srgbClr val="4A90E2"/>
           </a:solidFill>
-          <a:ln w="19050">
+          <a:ln w="15240">
             <a:solidFill>
               <a:srgbClr val="1A252C"/>
             </a:solidFill>
@@ -3714,102 +3397,22 @@
           </a:fontRef>
         </p:style>
         <p:txBody>
-          <a:bodyPr rtlCol="0" anchor="ctr" wrap="square" tIns="182880" lIns="73152" rIns="73152"/>
+          <a:bodyPr rtlCol="0" anchor="ctr" wrap="square" tIns="36576" bIns="36576" lIns="36576" rIns="36576"/>
           <a:lstStyle/>
           <a:p>
             <a:pPr algn="ctr">
-              <a:defRPr b="1" sz="1200">
+              <a:defRPr sz="850" b="1">
                 <a:solidFill>
                   <a:srgbClr val="FFFFFF"/>
                 </a:solidFill>
               </a:defRPr>
             </a:pPr>
             <a:r>
-              <a:t>Stage 3</a:t>
-            </a:r>
-          </a:p>
-          <a:p>
-            <a:pPr algn="ctr">
-              <a:defRPr sz="800">
-                <a:solidFill>
-                  <a:srgbClr val="FFFFFF"/>
-                </a:solidFill>
-              </a:defRPr>
-            </a:pPr>
-            <a:r>
-              <a:t>─────────</a:t>
-            </a:r>
-          </a:p>
-          <a:p>
-            <a:pPr algn="ctr">
-              <a:defRPr sz="950" b="0">
-                <a:solidFill>
-                  <a:srgbClr val="FFFFFF"/>
-                </a:solidFill>
-              </a:defRPr>
-            </a:pPr>
-            <a:r>
-              <a:t>BCResBlock (128)</a:t>
-            </a:r>
-          </a:p>
-          <a:p>
-            <a:pPr algn="ctr">
-              <a:defRPr sz="950" b="0">
-                <a:solidFill>
-                  <a:srgbClr val="FFFFFF"/>
-                </a:solidFill>
-              </a:defRPr>
-            </a:pPr>
-            <a:r>
-              <a:t>FreqConv (3×1)</a:t>
-            </a:r>
-          </a:p>
-          <a:p>
-            <a:pPr algn="ctr">
-              <a:defRPr sz="950" b="0">
-                <a:solidFill>
-                  <a:srgbClr val="FFFFFF"/>
-                </a:solidFill>
-              </a:defRPr>
-            </a:pPr>
-            <a:r>
-              <a:t>Stride = 2</a:t>
-            </a:r>
-          </a:p>
-          <a:p>
-            <a:pPr algn="ctr">
-              <a:defRPr sz="950" b="0">
-                <a:solidFill>
-                  <a:srgbClr val="FFFFFF"/>
-                </a:solidFill>
-              </a:defRPr>
-            </a:pPr>
-            <a:r>
-              <a:t>Broadcast Attn</a:t>
-            </a:r>
-          </a:p>
-          <a:p>
-            <a:pPr algn="ctr">
-              <a:defRPr sz="950" b="0">
-                <a:solidFill>
-                  <a:srgbClr val="FFFFFF"/>
-                </a:solidFill>
-              </a:defRPr>
-            </a:pPr>
-            <a:r>
-              <a:t>Proj Shortcut</a:t>
-            </a:r>
-          </a:p>
-          <a:p>
-            <a:pPr algn="ctr">
-              <a:defRPr sz="950" b="1">
-                <a:solidFill>
-                  <a:srgbClr val="FFFFFF"/>
-                </a:solidFill>
-              </a:defRPr>
-            </a:pPr>
-            <a:r>
-              <a:t>Out: 128×32×16</a:t>
+              <a:t>Freq-Conv (3x1)</a:t>
+            </a:r>
+            <a:br/>
+            <a:r>
+              <a:t>(32 flt, g=32)</a:t>
             </a:r>
           </a:p>
         </p:txBody>
@@ -3822,8 +3425,8 @@
         </p:nvSpPr>
         <p:spPr>
           <a:xfrm>
-            <a:off x="8778240" y="1371600"/>
-            <a:ext cx="1417320" cy="4206240"/>
+            <a:off x="2240280" y="2743200"/>
+            <a:ext cx="1371600" cy="685800"/>
           </a:xfrm>
           <a:prstGeom prst="roundRect">
             <a:avLst/>
@@ -3831,7 +3434,7 @@
           <a:solidFill>
             <a:srgbClr val="4A90E2"/>
           </a:solidFill>
-          <a:ln w="19050">
+          <a:ln w="15240">
             <a:solidFill>
               <a:srgbClr val="1A252C"/>
             </a:solidFill>
@@ -3852,102 +3455,22 @@
           </a:fontRef>
         </p:style>
         <p:txBody>
-          <a:bodyPr rtlCol="0" anchor="ctr" wrap="square" tIns="182880" lIns="73152" rIns="73152"/>
+          <a:bodyPr rtlCol="0" anchor="ctr" wrap="square" tIns="36576" bIns="36576" lIns="36576" rIns="36576"/>
           <a:lstStyle/>
           <a:p>
             <a:pPr algn="ctr">
-              <a:defRPr b="1" sz="1200">
+              <a:defRPr sz="850" b="1">
                 <a:solidFill>
                   <a:srgbClr val="FFFFFF"/>
                 </a:solidFill>
               </a:defRPr>
             </a:pPr>
             <a:r>
-              <a:t>Stage 4</a:t>
-            </a:r>
-          </a:p>
-          <a:p>
-            <a:pPr algn="ctr">
-              <a:defRPr sz="800">
-                <a:solidFill>
-                  <a:srgbClr val="FFFFFF"/>
-                </a:solidFill>
-              </a:defRPr>
-            </a:pPr>
-            <a:r>
-              <a:t>─────────</a:t>
-            </a:r>
-          </a:p>
-          <a:p>
-            <a:pPr algn="ctr">
-              <a:defRPr sz="950" b="0">
-                <a:solidFill>
-                  <a:srgbClr val="FFFFFF"/>
-                </a:solidFill>
-              </a:defRPr>
-            </a:pPr>
-            <a:r>
-              <a:t>BCResBlock (128)</a:t>
-            </a:r>
-          </a:p>
-          <a:p>
-            <a:pPr algn="ctr">
-              <a:defRPr sz="950" b="0">
-                <a:solidFill>
-                  <a:srgbClr val="FFFFFF"/>
-                </a:solidFill>
-              </a:defRPr>
-            </a:pPr>
-            <a:r>
-              <a:t>FreqConv (3×1)</a:t>
-            </a:r>
-          </a:p>
-          <a:p>
-            <a:pPr algn="ctr">
-              <a:defRPr sz="950" b="0">
-                <a:solidFill>
-                  <a:srgbClr val="FFFFFF"/>
-                </a:solidFill>
-              </a:defRPr>
-            </a:pPr>
-            <a:r>
-              <a:t>Stride = 1</a:t>
-            </a:r>
-          </a:p>
-          <a:p>
-            <a:pPr algn="ctr">
-              <a:defRPr sz="950" b="0">
-                <a:solidFill>
-                  <a:srgbClr val="FFFFFF"/>
-                </a:solidFill>
-              </a:defRPr>
-            </a:pPr>
-            <a:r>
-              <a:t>Broadcast Attn</a:t>
-            </a:r>
-          </a:p>
-          <a:p>
-            <a:pPr algn="ctr">
-              <a:defRPr sz="950" b="0">
-                <a:solidFill>
-                  <a:srgbClr val="FFFFFF"/>
-                </a:solidFill>
-              </a:defRPr>
-            </a:pPr>
-            <a:r>
-              <a:t>Identity Shortcut</a:t>
-            </a:r>
-          </a:p>
-          <a:p>
-            <a:pPr algn="ctr">
-              <a:defRPr sz="950" b="1">
-                <a:solidFill>
-                  <a:srgbClr val="FFFFFF"/>
-                </a:solidFill>
-              </a:defRPr>
-            </a:pPr>
-            <a:r>
-              <a:t>Out: 128×32×16</a:t>
+              <a:t>Pointwise (1x1)</a:t>
+            </a:r>
+            <a:br/>
+            <a:r>
+              <a:t>(32 flt, + BN)</a:t>
             </a:r>
           </a:p>
         </p:txBody>
@@ -3960,16 +3483,16 @@
         </p:nvSpPr>
         <p:spPr>
           <a:xfrm>
-            <a:off x="10424160" y="1371600"/>
-            <a:ext cx="1325880" cy="4206240"/>
+            <a:off x="2240280" y="3657600"/>
+            <a:ext cx="1371600" cy="685800"/>
           </a:xfrm>
           <a:prstGeom prst="roundRect">
             <a:avLst/>
           </a:prstGeom>
           <a:solidFill>
-            <a:srgbClr val="6A1B9A"/>
-          </a:solidFill>
-          <a:ln w="19050">
+            <a:srgbClr val="D81B60"/>
+          </a:solidFill>
+          <a:ln w="15240">
             <a:solidFill>
               <a:srgbClr val="1A252C"/>
             </a:solidFill>
@@ -3990,125 +3513,47 @@
           </a:fontRef>
         </p:style>
         <p:txBody>
-          <a:bodyPr rtlCol="0" anchor="ctr" wrap="square" tIns="182880" lIns="73152" rIns="73152"/>
+          <a:bodyPr rtlCol="0" anchor="ctr" wrap="square" tIns="36576" bIns="36576" lIns="36576" rIns="36576"/>
           <a:lstStyle/>
           <a:p>
             <a:pPr algn="ctr">
-              <a:defRPr b="1" sz="1200">
+              <a:defRPr sz="850" b="1">
                 <a:solidFill>
                   <a:srgbClr val="FFFFFF"/>
                 </a:solidFill>
               </a:defRPr>
             </a:pPr>
             <a:r>
-              <a:t>Classifier Head</a:t>
-            </a:r>
-          </a:p>
-          <a:p>
-            <a:pPr algn="ctr">
-              <a:defRPr sz="800">
-                <a:solidFill>
-                  <a:srgbClr val="FFFFFF"/>
-                </a:solidFill>
-              </a:defRPr>
-            </a:pPr>
-            <a:r>
-              <a:t>─────────</a:t>
-            </a:r>
-          </a:p>
-          <a:p>
-            <a:pPr algn="ctr">
-              <a:defRPr sz="950" b="0">
-                <a:solidFill>
-                  <a:srgbClr val="FFFFFF"/>
-                </a:solidFill>
-              </a:defRPr>
-            </a:pPr>
-            <a:r>
-              <a:t>Global Avg Pool</a:t>
-            </a:r>
-          </a:p>
-          <a:p>
-            <a:pPr algn="ctr">
-              <a:defRPr sz="950" b="0">
-                <a:solidFill>
-                  <a:srgbClr val="FFFFFF"/>
-                </a:solidFill>
-              </a:defRPr>
-            </a:pPr>
-            <a:r>
-              <a:t>128-d Vector</a:t>
-            </a:r>
-          </a:p>
-          <a:p>
-            <a:pPr algn="ctr">
-              <a:defRPr sz="950" b="0">
-                <a:solidFill>
-                  <a:srgbClr val="FFFFFF"/>
-                </a:solidFill>
-              </a:defRPr>
-            </a:pPr>
-            <a:r>
-              <a:t>Dropout (p=0.15)</a:t>
-            </a:r>
-          </a:p>
-          <a:p>
-            <a:pPr algn="ctr">
-              <a:defRPr sz="950" b="0">
-                <a:solidFill>
-                  <a:srgbClr val="FFFFFF"/>
-                </a:solidFill>
-              </a:defRPr>
-            </a:pPr>
-            <a:r>
-              <a:t>Dense (128→7)</a:t>
-            </a:r>
-          </a:p>
-          <a:p>
-            <a:pPr algn="ctr">
-              <a:defRPr sz="950" b="0">
-                <a:solidFill>
-                  <a:srgbClr val="FFFFFF"/>
-                </a:solidFill>
-              </a:defRPr>
-            </a:pPr>
-            <a:r>
-              <a:t>Softmax Output</a:t>
-            </a:r>
-          </a:p>
-          <a:p>
-            <a:pPr algn="ctr">
-              <a:defRPr sz="950" b="0">
-                <a:solidFill>
-                  <a:srgbClr val="FFFFFF"/>
-                </a:solidFill>
-              </a:defRPr>
-            </a:pPr>
-            <a:r>
-              <a:t>7 Command Classes</a:t>
-            </a:r>
-          </a:p>
-        </p:txBody>
-      </p:sp>
-      <p:sp>
-        <p:nvSpPr>
-          <p:cNvPr id="10" name="Right Arrow 9"/>
+              <a:t>Broadcast Attn</a:t>
+            </a:r>
+            <a:br/>
+            <a:r>
+              <a:t>(BFA Operator)</a:t>
+            </a:r>
+          </a:p>
+        </p:txBody>
+      </p:sp>
+      <p:sp>
+        <p:nvSpPr>
+          <p:cNvPr id="10" name="Rounded Rectangle 9"/>
           <p:cNvSpPr/>
           <p:nvPr/>
         </p:nvSpPr>
         <p:spPr>
           <a:xfrm>
-            <a:off x="2075688" y="3337560"/>
-            <a:ext cx="192023" cy="274320"/>
-          </a:xfrm>
-          <a:prstGeom prst="rightArrow">
+            <a:off x="2240280" y="4572000"/>
+            <a:ext cx="1371600" cy="685800"/>
+          </a:xfrm>
+          <a:prstGeom prst="roundRect">
             <a:avLst/>
           </a:prstGeom>
           <a:solidFill>
-            <a:srgbClr val="1976D2"/>
-          </a:solidFill>
-          <a:ln>
-            <a:noFill/>
+            <a:srgbClr val="00838F"/>
+          </a:solidFill>
+          <a:ln w="15240">
+            <a:solidFill>
+              <a:srgbClr val="1A252C"/>
+            </a:solidFill>
           </a:ln>
         </p:spPr>
         <p:style>
@@ -4126,32 +3571,47 @@
           </a:fontRef>
         </p:style>
         <p:txBody>
-          <a:bodyPr rtlCol="0" anchor="ctr"/>
-          <a:lstStyle/>
-          <a:p>
-            <a:pPr algn="ctr"/>
-          </a:p>
-        </p:txBody>
-      </p:sp>
-      <p:sp>
-        <p:nvSpPr>
-          <p:cNvPr id="11" name="Right Arrow 10"/>
+          <a:bodyPr rtlCol="0" anchor="ctr" wrap="square" tIns="36576" bIns="36576" lIns="36576" rIns="36576"/>
+          <a:lstStyle/>
+          <a:p>
+            <a:pPr algn="ctr">
+              <a:defRPr sz="850" b="1">
+                <a:solidFill>
+                  <a:srgbClr val="FFFFFF"/>
+                </a:solidFill>
+              </a:defRPr>
+            </a:pPr>
+            <a:r>
+              <a:t>Add [F(x) + x]</a:t>
+            </a:r>
+            <a:br/>
+            <a:r>
+              <a:t>+ ReLU (32,128,63)</a:t>
+            </a:r>
+          </a:p>
+        </p:txBody>
+      </p:sp>
+      <p:sp>
+        <p:nvSpPr>
+          <p:cNvPr id="11" name="Rounded Rectangle 10"/>
           <p:cNvSpPr/>
           <p:nvPr/>
         </p:nvSpPr>
         <p:spPr>
           <a:xfrm>
-            <a:off x="3630168" y="3337560"/>
-            <a:ext cx="192024" cy="274320"/>
-          </a:xfrm>
-          <a:prstGeom prst="rightArrow">
+            <a:off x="4023360" y="1554480"/>
+            <a:ext cx="1645920" cy="3931920"/>
+          </a:xfrm>
+          <a:prstGeom prst="roundRect">
             <a:avLst/>
           </a:prstGeom>
           <a:solidFill>
-            <a:srgbClr val="1976D2"/>
-          </a:solidFill>
-          <a:ln>
-            <a:noFill/>
+            <a:srgbClr val="FFFBF5"/>
+          </a:solidFill>
+          <a:ln w="19050">
+            <a:solidFill>
+              <a:srgbClr val="E65100"/>
+            </a:solidFill>
           </a:ln>
         </p:spPr>
         <p:style>
@@ -4178,23 +3638,25 @@
       </p:sp>
       <p:sp>
         <p:nvSpPr>
-          <p:cNvPr id="12" name="Right Arrow 11"/>
+          <p:cNvPr id="12" name="Rounded Rectangle 11"/>
           <p:cNvSpPr/>
           <p:nvPr/>
         </p:nvSpPr>
         <p:spPr>
           <a:xfrm>
-            <a:off x="5276088" y="3337560"/>
-            <a:ext cx="192024" cy="274320"/>
-          </a:xfrm>
-          <a:prstGeom prst="rightArrow">
+            <a:off x="4114800" y="1408176"/>
+            <a:ext cx="1463040" cy="292608"/>
+          </a:xfrm>
+          <a:prstGeom prst="roundRect">
             <a:avLst/>
           </a:prstGeom>
           <a:solidFill>
-            <a:srgbClr val="1976D2"/>
-          </a:solidFill>
-          <a:ln>
-            <a:noFill/>
+            <a:srgbClr val="FFE0B2"/>
+          </a:solidFill>
+          <a:ln w="12700">
+            <a:solidFill>
+              <a:srgbClr val="E65100"/>
+            </a:solidFill>
           </a:ln>
         </p:spPr>
         <p:style>
@@ -4215,29 +3677,40 @@
           <a:bodyPr rtlCol="0" anchor="ctr"/>
           <a:lstStyle/>
           <a:p>
-            <a:pPr algn="ctr"/>
-          </a:p>
-        </p:txBody>
-      </p:sp>
-      <p:sp>
-        <p:nvSpPr>
-          <p:cNvPr id="13" name="Right Arrow 12"/>
+            <a:pPr algn="ctr">
+              <a:defRPr sz="850" b="1">
+                <a:solidFill>
+                  <a:srgbClr val="BF360C"/>
+                </a:solidFill>
+              </a:defRPr>
+            </a:pPr>
+            <a:r>
+              <a:t>BC-ResBlock 2 (s=2)</a:t>
+            </a:r>
+          </a:p>
+        </p:txBody>
+      </p:sp>
+      <p:sp>
+        <p:nvSpPr>
+          <p:cNvPr id="13" name="Rounded Rectangle 12"/>
           <p:cNvSpPr/>
           <p:nvPr/>
         </p:nvSpPr>
         <p:spPr>
           <a:xfrm>
-            <a:off x="6922007" y="3337560"/>
-            <a:ext cx="192024" cy="274320"/>
-          </a:xfrm>
-          <a:prstGeom prst="rightArrow">
+            <a:off x="4160520" y="1828800"/>
+            <a:ext cx="1371600" cy="685800"/>
+          </a:xfrm>
+          <a:prstGeom prst="roundRect">
             <a:avLst/>
           </a:prstGeom>
           <a:solidFill>
-            <a:srgbClr val="1976D2"/>
-          </a:solidFill>
-          <a:ln>
-            <a:noFill/>
+            <a:srgbClr val="4A90E2"/>
+          </a:solidFill>
+          <a:ln w="15240">
+            <a:solidFill>
+              <a:srgbClr val="1A252C"/>
+            </a:solidFill>
           </a:ln>
         </p:spPr>
         <p:style>
@@ -4255,32 +3728,47 @@
           </a:fontRef>
         </p:style>
         <p:txBody>
-          <a:bodyPr rtlCol="0" anchor="ctr"/>
-          <a:lstStyle/>
-          <a:p>
-            <a:pPr algn="ctr"/>
-          </a:p>
-        </p:txBody>
-      </p:sp>
-      <p:sp>
-        <p:nvSpPr>
-          <p:cNvPr id="14" name="Right Arrow 13"/>
+          <a:bodyPr rtlCol="0" anchor="ctr" wrap="square" tIns="36576" bIns="36576" lIns="36576" rIns="36576"/>
+          <a:lstStyle/>
+          <a:p>
+            <a:pPr algn="ctr">
+              <a:defRPr sz="850" b="1">
+                <a:solidFill>
+                  <a:srgbClr val="FFFFFF"/>
+                </a:solidFill>
+              </a:defRPr>
+            </a:pPr>
+            <a:r>
+              <a:t>Freq-Conv (3x1)</a:t>
+            </a:r>
+            <a:br/>
+            <a:r>
+              <a:t>(64 flt, s=2)</a:t>
+            </a:r>
+          </a:p>
+        </p:txBody>
+      </p:sp>
+      <p:sp>
+        <p:nvSpPr>
+          <p:cNvPr id="14" name="Rounded Rectangle 13"/>
           <p:cNvSpPr/>
           <p:nvPr/>
         </p:nvSpPr>
         <p:spPr>
           <a:xfrm>
-            <a:off x="8567928" y="3337560"/>
-            <a:ext cx="192024" cy="274320"/>
-          </a:xfrm>
-          <a:prstGeom prst="rightArrow">
+            <a:off x="4160520" y="2743200"/>
+            <a:ext cx="1371600" cy="685800"/>
+          </a:xfrm>
+          <a:prstGeom prst="roundRect">
             <a:avLst/>
           </a:prstGeom>
           <a:solidFill>
-            <a:srgbClr val="1976D2"/>
-          </a:solidFill>
-          <a:ln>
-            <a:noFill/>
+            <a:srgbClr val="4A90E2"/>
+          </a:solidFill>
+          <a:ln w="15240">
+            <a:solidFill>
+              <a:srgbClr val="1A252C"/>
+            </a:solidFill>
           </a:ln>
         </p:spPr>
         <p:style>
@@ -4298,32 +3786,47 @@
           </a:fontRef>
         </p:style>
         <p:txBody>
-          <a:bodyPr rtlCol="0" anchor="ctr"/>
-          <a:lstStyle/>
-          <a:p>
-            <a:pPr algn="ctr"/>
-          </a:p>
-        </p:txBody>
-      </p:sp>
-      <p:sp>
-        <p:nvSpPr>
-          <p:cNvPr id="15" name="Right Arrow 14"/>
+          <a:bodyPr rtlCol="0" anchor="ctr" wrap="square" tIns="36576" bIns="36576" lIns="36576" rIns="36576"/>
+          <a:lstStyle/>
+          <a:p>
+            <a:pPr algn="ctr">
+              <a:defRPr sz="850" b="1">
+                <a:solidFill>
+                  <a:srgbClr val="FFFFFF"/>
+                </a:solidFill>
+              </a:defRPr>
+            </a:pPr>
+            <a:r>
+              <a:t>Pointwise (1x1)</a:t>
+            </a:r>
+            <a:br/>
+            <a:r>
+              <a:t>(64 flt, + BN)</a:t>
+            </a:r>
+          </a:p>
+        </p:txBody>
+      </p:sp>
+      <p:sp>
+        <p:nvSpPr>
+          <p:cNvPr id="15" name="Rounded Rectangle 14"/>
           <p:cNvSpPr/>
           <p:nvPr/>
         </p:nvSpPr>
         <p:spPr>
           <a:xfrm>
-            <a:off x="10213848" y="3337560"/>
-            <a:ext cx="192024" cy="274320"/>
-          </a:xfrm>
-          <a:prstGeom prst="rightArrow">
+            <a:off x="4160520" y="3657600"/>
+            <a:ext cx="1371600" cy="685800"/>
+          </a:xfrm>
+          <a:prstGeom prst="roundRect">
             <a:avLst/>
           </a:prstGeom>
           <a:solidFill>
-            <a:srgbClr val="1976D2"/>
-          </a:solidFill>
-          <a:ln>
-            <a:noFill/>
+            <a:srgbClr val="D81B60"/>
+          </a:solidFill>
+          <a:ln w="15240">
+            <a:solidFill>
+              <a:srgbClr val="1A252C"/>
+            </a:solidFill>
           </a:ln>
         </p:spPr>
         <p:style>
@@ -4341,6 +3844,122 @@
           </a:fontRef>
         </p:style>
         <p:txBody>
+          <a:bodyPr rtlCol="0" anchor="ctr" wrap="square" tIns="36576" bIns="36576" lIns="36576" rIns="36576"/>
+          <a:lstStyle/>
+          <a:p>
+            <a:pPr algn="ctr">
+              <a:defRPr sz="850" b="1">
+                <a:solidFill>
+                  <a:srgbClr val="FFFFFF"/>
+                </a:solidFill>
+              </a:defRPr>
+            </a:pPr>
+            <a:r>
+              <a:t>Broadcast Attn</a:t>
+            </a:r>
+            <a:br/>
+            <a:r>
+              <a:t>(BFA Operator)</a:t>
+            </a:r>
+          </a:p>
+        </p:txBody>
+      </p:sp>
+      <p:sp>
+        <p:nvSpPr>
+          <p:cNvPr id="16" name="Rounded Rectangle 15"/>
+          <p:cNvSpPr/>
+          <p:nvPr/>
+        </p:nvSpPr>
+        <p:spPr>
+          <a:xfrm>
+            <a:off x="4160520" y="4572000"/>
+            <a:ext cx="1371600" cy="685800"/>
+          </a:xfrm>
+          <a:prstGeom prst="roundRect">
+            <a:avLst/>
+          </a:prstGeom>
+          <a:solidFill>
+            <a:srgbClr val="00838F"/>
+          </a:solidFill>
+          <a:ln w="15240">
+            <a:solidFill>
+              <a:srgbClr val="1A252C"/>
+            </a:solidFill>
+          </a:ln>
+        </p:spPr>
+        <p:style>
+          <a:lnRef idx="1">
+            <a:schemeClr val="accent1"/>
+          </a:lnRef>
+          <a:fillRef idx="3">
+            <a:schemeClr val="accent1"/>
+          </a:fillRef>
+          <a:effectRef idx="2">
+            <a:schemeClr val="accent1"/>
+          </a:effectRef>
+          <a:fontRef idx="minor">
+            <a:schemeClr val="lt1"/>
+          </a:fontRef>
+        </p:style>
+        <p:txBody>
+          <a:bodyPr rtlCol="0" anchor="ctr" wrap="square" tIns="36576" bIns="36576" lIns="36576" rIns="36576"/>
+          <a:lstStyle/>
+          <a:p>
+            <a:pPr algn="ctr">
+              <a:defRPr sz="850" b="1">
+                <a:solidFill>
+                  <a:srgbClr val="FFFFFF"/>
+                </a:solidFill>
+              </a:defRPr>
+            </a:pPr>
+            <a:r>
+              <a:t>Add [F(x) + Ws*x]</a:t>
+            </a:r>
+            <a:br/>
+            <a:r>
+              <a:t>+ ReLU (64,64,32)</a:t>
+            </a:r>
+          </a:p>
+        </p:txBody>
+      </p:sp>
+      <p:sp>
+        <p:nvSpPr>
+          <p:cNvPr id="17" name="Rounded Rectangle 16"/>
+          <p:cNvSpPr/>
+          <p:nvPr/>
+        </p:nvSpPr>
+        <p:spPr>
+          <a:xfrm>
+            <a:off x="5943600" y="1554480"/>
+            <a:ext cx="1645920" cy="3931920"/>
+          </a:xfrm>
+          <a:prstGeom prst="roundRect">
+            <a:avLst/>
+          </a:prstGeom>
+          <a:solidFill>
+            <a:srgbClr val="FFFBF5"/>
+          </a:solidFill>
+          <a:ln w="19050">
+            <a:solidFill>
+              <a:srgbClr val="E65100"/>
+            </a:solidFill>
+          </a:ln>
+        </p:spPr>
+        <p:style>
+          <a:lnRef idx="1">
+            <a:schemeClr val="accent1"/>
+          </a:lnRef>
+          <a:fillRef idx="3">
+            <a:schemeClr val="accent1"/>
+          </a:fillRef>
+          <a:effectRef idx="2">
+            <a:schemeClr val="accent1"/>
+          </a:effectRef>
+          <a:fontRef idx="minor">
+            <a:schemeClr val="lt1"/>
+          </a:fontRef>
+        </p:style>
+        <p:txBody>
           <a:bodyPr rtlCol="0" anchor="ctr"/>
           <a:lstStyle/>
           <a:p>
@@ -4350,14 +3969,875 @@
       </p:sp>
       <p:sp>
         <p:nvSpPr>
-          <p:cNvPr id="16" name="TextBox 15"/>
+          <p:cNvPr id="18" name="Rounded Rectangle 17"/>
+          <p:cNvSpPr/>
+          <p:nvPr/>
+        </p:nvSpPr>
+        <p:spPr>
+          <a:xfrm>
+            <a:off x="6035040" y="1408176"/>
+            <a:ext cx="1463040" cy="292608"/>
+          </a:xfrm>
+          <a:prstGeom prst="roundRect">
+            <a:avLst/>
+          </a:prstGeom>
+          <a:solidFill>
+            <a:srgbClr val="FFE0B2"/>
+          </a:solidFill>
+          <a:ln w="12700">
+            <a:solidFill>
+              <a:srgbClr val="E65100"/>
+            </a:solidFill>
+          </a:ln>
+        </p:spPr>
+        <p:style>
+          <a:lnRef idx="1">
+            <a:schemeClr val="accent1"/>
+          </a:lnRef>
+          <a:fillRef idx="3">
+            <a:schemeClr val="accent1"/>
+          </a:fillRef>
+          <a:effectRef idx="2">
+            <a:schemeClr val="accent1"/>
+          </a:effectRef>
+          <a:fontRef idx="minor">
+            <a:schemeClr val="lt1"/>
+          </a:fontRef>
+        </p:style>
+        <p:txBody>
+          <a:bodyPr rtlCol="0" anchor="ctr"/>
+          <a:lstStyle/>
+          <a:p>
+            <a:pPr algn="ctr">
+              <a:defRPr sz="850" b="1">
+                <a:solidFill>
+                  <a:srgbClr val="BF360C"/>
+                </a:solidFill>
+              </a:defRPr>
+            </a:pPr>
+            <a:r>
+              <a:t>BC-ResBlock 3 (s=2)</a:t>
+            </a:r>
+          </a:p>
+        </p:txBody>
+      </p:sp>
+      <p:sp>
+        <p:nvSpPr>
+          <p:cNvPr id="19" name="Rounded Rectangle 18"/>
+          <p:cNvSpPr/>
+          <p:nvPr/>
+        </p:nvSpPr>
+        <p:spPr>
+          <a:xfrm>
+            <a:off x="6080760" y="1828800"/>
+            <a:ext cx="1371600" cy="685800"/>
+          </a:xfrm>
+          <a:prstGeom prst="roundRect">
+            <a:avLst/>
+          </a:prstGeom>
+          <a:solidFill>
+            <a:srgbClr val="4A90E2"/>
+          </a:solidFill>
+          <a:ln w="15240">
+            <a:solidFill>
+              <a:srgbClr val="1A252C"/>
+            </a:solidFill>
+          </a:ln>
+        </p:spPr>
+        <p:style>
+          <a:lnRef idx="1">
+            <a:schemeClr val="accent1"/>
+          </a:lnRef>
+          <a:fillRef idx="3">
+            <a:schemeClr val="accent1"/>
+          </a:fillRef>
+          <a:effectRef idx="2">
+            <a:schemeClr val="accent1"/>
+          </a:effectRef>
+          <a:fontRef idx="minor">
+            <a:schemeClr val="lt1"/>
+          </a:fontRef>
+        </p:style>
+        <p:txBody>
+          <a:bodyPr rtlCol="0" anchor="ctr" wrap="square" tIns="36576" bIns="36576" lIns="36576" rIns="36576"/>
+          <a:lstStyle/>
+          <a:p>
+            <a:pPr algn="ctr">
+              <a:defRPr sz="850" b="1">
+                <a:solidFill>
+                  <a:srgbClr val="FFFFFF"/>
+                </a:solidFill>
+              </a:defRPr>
+            </a:pPr>
+            <a:r>
+              <a:t>Freq-Conv (3x1)</a:t>
+            </a:r>
+            <a:br/>
+            <a:r>
+              <a:t>(128 flt, s=2)</a:t>
+            </a:r>
+          </a:p>
+        </p:txBody>
+      </p:sp>
+      <p:sp>
+        <p:nvSpPr>
+          <p:cNvPr id="20" name="Rounded Rectangle 19"/>
+          <p:cNvSpPr/>
+          <p:nvPr/>
+        </p:nvSpPr>
+        <p:spPr>
+          <a:xfrm>
+            <a:off x="6080760" y="2743200"/>
+            <a:ext cx="1371600" cy="685800"/>
+          </a:xfrm>
+          <a:prstGeom prst="roundRect">
+            <a:avLst/>
+          </a:prstGeom>
+          <a:solidFill>
+            <a:srgbClr val="4A90E2"/>
+          </a:solidFill>
+          <a:ln w="15240">
+            <a:solidFill>
+              <a:srgbClr val="1A252C"/>
+            </a:solidFill>
+          </a:ln>
+        </p:spPr>
+        <p:style>
+          <a:lnRef idx="1">
+            <a:schemeClr val="accent1"/>
+          </a:lnRef>
+          <a:fillRef idx="3">
+            <a:schemeClr val="accent1"/>
+          </a:fillRef>
+          <a:effectRef idx="2">
+            <a:schemeClr val="accent1"/>
+          </a:effectRef>
+          <a:fontRef idx="minor">
+            <a:schemeClr val="lt1"/>
+          </a:fontRef>
+        </p:style>
+        <p:txBody>
+          <a:bodyPr rtlCol="0" anchor="ctr" wrap="square" tIns="36576" bIns="36576" lIns="36576" rIns="36576"/>
+          <a:lstStyle/>
+          <a:p>
+            <a:pPr algn="ctr">
+              <a:defRPr sz="850" b="1">
+                <a:solidFill>
+                  <a:srgbClr val="FFFFFF"/>
+                </a:solidFill>
+              </a:defRPr>
+            </a:pPr>
+            <a:r>
+              <a:t>Pointwise (1x1)</a:t>
+            </a:r>
+            <a:br/>
+            <a:r>
+              <a:t>(128 flt, + BN)</a:t>
+            </a:r>
+          </a:p>
+        </p:txBody>
+      </p:sp>
+      <p:sp>
+        <p:nvSpPr>
+          <p:cNvPr id="21" name="Rounded Rectangle 20"/>
+          <p:cNvSpPr/>
+          <p:nvPr/>
+        </p:nvSpPr>
+        <p:spPr>
+          <a:xfrm>
+            <a:off x="6080760" y="3657600"/>
+            <a:ext cx="1371600" cy="685800"/>
+          </a:xfrm>
+          <a:prstGeom prst="roundRect">
+            <a:avLst/>
+          </a:prstGeom>
+          <a:solidFill>
+            <a:srgbClr val="D81B60"/>
+          </a:solidFill>
+          <a:ln w="15240">
+            <a:solidFill>
+              <a:srgbClr val="1A252C"/>
+            </a:solidFill>
+          </a:ln>
+        </p:spPr>
+        <p:style>
+          <a:lnRef idx="1">
+            <a:schemeClr val="accent1"/>
+          </a:lnRef>
+          <a:fillRef idx="3">
+            <a:schemeClr val="accent1"/>
+          </a:fillRef>
+          <a:effectRef idx="2">
+            <a:schemeClr val="accent1"/>
+          </a:effectRef>
+          <a:fontRef idx="minor">
+            <a:schemeClr val="lt1"/>
+          </a:fontRef>
+        </p:style>
+        <p:txBody>
+          <a:bodyPr rtlCol="0" anchor="ctr" wrap="square" tIns="36576" bIns="36576" lIns="36576" rIns="36576"/>
+          <a:lstStyle/>
+          <a:p>
+            <a:pPr algn="ctr">
+              <a:defRPr sz="850" b="1">
+                <a:solidFill>
+                  <a:srgbClr val="FFFFFF"/>
+                </a:solidFill>
+              </a:defRPr>
+            </a:pPr>
+            <a:r>
+              <a:t>Broadcast Attn</a:t>
+            </a:r>
+            <a:br/>
+            <a:r>
+              <a:t>(BFA Operator)</a:t>
+            </a:r>
+          </a:p>
+        </p:txBody>
+      </p:sp>
+      <p:sp>
+        <p:nvSpPr>
+          <p:cNvPr id="22" name="Rounded Rectangle 21"/>
+          <p:cNvSpPr/>
+          <p:nvPr/>
+        </p:nvSpPr>
+        <p:spPr>
+          <a:xfrm>
+            <a:off x="6080760" y="4572000"/>
+            <a:ext cx="1371600" cy="685800"/>
+          </a:xfrm>
+          <a:prstGeom prst="roundRect">
+            <a:avLst/>
+          </a:prstGeom>
+          <a:solidFill>
+            <a:srgbClr val="00838F"/>
+          </a:solidFill>
+          <a:ln w="15240">
+            <a:solidFill>
+              <a:srgbClr val="1A252C"/>
+            </a:solidFill>
+          </a:ln>
+        </p:spPr>
+        <p:style>
+          <a:lnRef idx="1">
+            <a:schemeClr val="accent1"/>
+          </a:lnRef>
+          <a:fillRef idx="3">
+            <a:schemeClr val="accent1"/>
+          </a:fillRef>
+          <a:effectRef idx="2">
+            <a:schemeClr val="accent1"/>
+          </a:effectRef>
+          <a:fontRef idx="minor">
+            <a:schemeClr val="lt1"/>
+          </a:fontRef>
+        </p:style>
+        <p:txBody>
+          <a:bodyPr rtlCol="0" anchor="ctr" wrap="square" tIns="36576" bIns="36576" lIns="36576" rIns="36576"/>
+          <a:lstStyle/>
+          <a:p>
+            <a:pPr algn="ctr">
+              <a:defRPr sz="850" b="1">
+                <a:solidFill>
+                  <a:srgbClr val="FFFFFF"/>
+                </a:solidFill>
+              </a:defRPr>
+            </a:pPr>
+            <a:r>
+              <a:t>Add [F(x) + Ws*x]</a:t>
+            </a:r>
+            <a:br/>
+            <a:r>
+              <a:t>+ ReLU (128,32,16)</a:t>
+            </a:r>
+          </a:p>
+        </p:txBody>
+      </p:sp>
+      <p:sp>
+        <p:nvSpPr>
+          <p:cNvPr id="23" name="Rounded Rectangle 22"/>
+          <p:cNvSpPr/>
+          <p:nvPr/>
+        </p:nvSpPr>
+        <p:spPr>
+          <a:xfrm>
+            <a:off x="7863840" y="1554480"/>
+            <a:ext cx="1645920" cy="3931920"/>
+          </a:xfrm>
+          <a:prstGeom prst="roundRect">
+            <a:avLst/>
+          </a:prstGeom>
+          <a:solidFill>
+            <a:srgbClr val="FFFBF5"/>
+          </a:solidFill>
+          <a:ln w="19050">
+            <a:solidFill>
+              <a:srgbClr val="E65100"/>
+            </a:solidFill>
+          </a:ln>
+        </p:spPr>
+        <p:style>
+          <a:lnRef idx="1">
+            <a:schemeClr val="accent1"/>
+          </a:lnRef>
+          <a:fillRef idx="3">
+            <a:schemeClr val="accent1"/>
+          </a:fillRef>
+          <a:effectRef idx="2">
+            <a:schemeClr val="accent1"/>
+          </a:effectRef>
+          <a:fontRef idx="minor">
+            <a:schemeClr val="lt1"/>
+          </a:fontRef>
+        </p:style>
+        <p:txBody>
+          <a:bodyPr rtlCol="0" anchor="ctr"/>
+          <a:lstStyle/>
+          <a:p>
+            <a:pPr algn="ctr"/>
+          </a:p>
+        </p:txBody>
+      </p:sp>
+      <p:sp>
+        <p:nvSpPr>
+          <p:cNvPr id="24" name="Rounded Rectangle 23"/>
+          <p:cNvSpPr/>
+          <p:nvPr/>
+        </p:nvSpPr>
+        <p:spPr>
+          <a:xfrm>
+            <a:off x="7955279" y="1408176"/>
+            <a:ext cx="1463040" cy="292608"/>
+          </a:xfrm>
+          <a:prstGeom prst="roundRect">
+            <a:avLst/>
+          </a:prstGeom>
+          <a:solidFill>
+            <a:srgbClr val="FFE0B2"/>
+          </a:solidFill>
+          <a:ln w="12700">
+            <a:solidFill>
+              <a:srgbClr val="E65100"/>
+            </a:solidFill>
+          </a:ln>
+        </p:spPr>
+        <p:style>
+          <a:lnRef idx="1">
+            <a:schemeClr val="accent1"/>
+          </a:lnRef>
+          <a:fillRef idx="3">
+            <a:schemeClr val="accent1"/>
+          </a:fillRef>
+          <a:effectRef idx="2">
+            <a:schemeClr val="accent1"/>
+          </a:effectRef>
+          <a:fontRef idx="minor">
+            <a:schemeClr val="lt1"/>
+          </a:fontRef>
+        </p:style>
+        <p:txBody>
+          <a:bodyPr rtlCol="0" anchor="ctr"/>
+          <a:lstStyle/>
+          <a:p>
+            <a:pPr algn="ctr">
+              <a:defRPr sz="850" b="1">
+                <a:solidFill>
+                  <a:srgbClr val="BF360C"/>
+                </a:solidFill>
+              </a:defRPr>
+            </a:pPr>
+            <a:r>
+              <a:t>BC-ResBlock 4 (s=1)</a:t>
+            </a:r>
+          </a:p>
+        </p:txBody>
+      </p:sp>
+      <p:sp>
+        <p:nvSpPr>
+          <p:cNvPr id="25" name="Rounded Rectangle 24"/>
+          <p:cNvSpPr/>
+          <p:nvPr/>
+        </p:nvSpPr>
+        <p:spPr>
+          <a:xfrm>
+            <a:off x="8001000" y="1828800"/>
+            <a:ext cx="1371600" cy="685800"/>
+          </a:xfrm>
+          <a:prstGeom prst="roundRect">
+            <a:avLst/>
+          </a:prstGeom>
+          <a:solidFill>
+            <a:srgbClr val="4A90E2"/>
+          </a:solidFill>
+          <a:ln w="15240">
+            <a:solidFill>
+              <a:srgbClr val="1A252C"/>
+            </a:solidFill>
+          </a:ln>
+        </p:spPr>
+        <p:style>
+          <a:lnRef idx="1">
+            <a:schemeClr val="accent1"/>
+          </a:lnRef>
+          <a:fillRef idx="3">
+            <a:schemeClr val="accent1"/>
+          </a:fillRef>
+          <a:effectRef idx="2">
+            <a:schemeClr val="accent1"/>
+          </a:effectRef>
+          <a:fontRef idx="minor">
+            <a:schemeClr val="lt1"/>
+          </a:fontRef>
+        </p:style>
+        <p:txBody>
+          <a:bodyPr rtlCol="0" anchor="ctr" wrap="square" tIns="36576" bIns="36576" lIns="36576" rIns="36576"/>
+          <a:lstStyle/>
+          <a:p>
+            <a:pPr algn="ctr">
+              <a:defRPr sz="850" b="1">
+                <a:solidFill>
+                  <a:srgbClr val="FFFFFF"/>
+                </a:solidFill>
+              </a:defRPr>
+            </a:pPr>
+            <a:r>
+              <a:t>Freq-Conv (3x1)</a:t>
+            </a:r>
+            <a:br/>
+            <a:r>
+              <a:t>(128 flt, s=1)</a:t>
+            </a:r>
+          </a:p>
+        </p:txBody>
+      </p:sp>
+      <p:sp>
+        <p:nvSpPr>
+          <p:cNvPr id="26" name="Rounded Rectangle 25"/>
+          <p:cNvSpPr/>
+          <p:nvPr/>
+        </p:nvSpPr>
+        <p:spPr>
+          <a:xfrm>
+            <a:off x="8001000" y="2743200"/>
+            <a:ext cx="1371600" cy="685800"/>
+          </a:xfrm>
+          <a:prstGeom prst="roundRect">
+            <a:avLst/>
+          </a:prstGeom>
+          <a:solidFill>
+            <a:srgbClr val="4A90E2"/>
+          </a:solidFill>
+          <a:ln w="15240">
+            <a:solidFill>
+              <a:srgbClr val="1A252C"/>
+            </a:solidFill>
+          </a:ln>
+        </p:spPr>
+        <p:style>
+          <a:lnRef idx="1">
+            <a:schemeClr val="accent1"/>
+          </a:lnRef>
+          <a:fillRef idx="3">
+            <a:schemeClr val="accent1"/>
+          </a:fillRef>
+          <a:effectRef idx="2">
+            <a:schemeClr val="accent1"/>
+          </a:effectRef>
+          <a:fontRef idx="minor">
+            <a:schemeClr val="lt1"/>
+          </a:fontRef>
+        </p:style>
+        <p:txBody>
+          <a:bodyPr rtlCol="0" anchor="ctr" wrap="square" tIns="36576" bIns="36576" lIns="36576" rIns="36576"/>
+          <a:lstStyle/>
+          <a:p>
+            <a:pPr algn="ctr">
+              <a:defRPr sz="850" b="1">
+                <a:solidFill>
+                  <a:srgbClr val="FFFFFF"/>
+                </a:solidFill>
+              </a:defRPr>
+            </a:pPr>
+            <a:r>
+              <a:t>Pointwise (1x1)</a:t>
+            </a:r>
+            <a:br/>
+            <a:r>
+              <a:t>(128 flt, + BN)</a:t>
+            </a:r>
+          </a:p>
+        </p:txBody>
+      </p:sp>
+      <p:sp>
+        <p:nvSpPr>
+          <p:cNvPr id="27" name="Rounded Rectangle 26"/>
+          <p:cNvSpPr/>
+          <p:nvPr/>
+        </p:nvSpPr>
+        <p:spPr>
+          <a:xfrm>
+            <a:off x="8001000" y="3657600"/>
+            <a:ext cx="1371600" cy="685800"/>
+          </a:xfrm>
+          <a:prstGeom prst="roundRect">
+            <a:avLst/>
+          </a:prstGeom>
+          <a:solidFill>
+            <a:srgbClr val="D81B60"/>
+          </a:solidFill>
+          <a:ln w="15240">
+            <a:solidFill>
+              <a:srgbClr val="1A252C"/>
+            </a:solidFill>
+          </a:ln>
+        </p:spPr>
+        <p:style>
+          <a:lnRef idx="1">
+            <a:schemeClr val="accent1"/>
+          </a:lnRef>
+          <a:fillRef idx="3">
+            <a:schemeClr val="accent1"/>
+          </a:fillRef>
+          <a:effectRef idx="2">
+            <a:schemeClr val="accent1"/>
+          </a:effectRef>
+          <a:fontRef idx="minor">
+            <a:schemeClr val="lt1"/>
+          </a:fontRef>
+        </p:style>
+        <p:txBody>
+          <a:bodyPr rtlCol="0" anchor="ctr" wrap="square" tIns="36576" bIns="36576" lIns="36576" rIns="36576"/>
+          <a:lstStyle/>
+          <a:p>
+            <a:pPr algn="ctr">
+              <a:defRPr sz="850" b="1">
+                <a:solidFill>
+                  <a:srgbClr val="FFFFFF"/>
+                </a:solidFill>
+              </a:defRPr>
+            </a:pPr>
+            <a:r>
+              <a:t>Broadcast Attn</a:t>
+            </a:r>
+            <a:br/>
+            <a:r>
+              <a:t>(BFA Operator)</a:t>
+            </a:r>
+          </a:p>
+        </p:txBody>
+      </p:sp>
+      <p:sp>
+        <p:nvSpPr>
+          <p:cNvPr id="28" name="Rounded Rectangle 27"/>
+          <p:cNvSpPr/>
+          <p:nvPr/>
+        </p:nvSpPr>
+        <p:spPr>
+          <a:xfrm>
+            <a:off x="8001000" y="4572000"/>
+            <a:ext cx="1371600" cy="685800"/>
+          </a:xfrm>
+          <a:prstGeom prst="roundRect">
+            <a:avLst/>
+          </a:prstGeom>
+          <a:solidFill>
+            <a:srgbClr val="00838F"/>
+          </a:solidFill>
+          <a:ln w="15240">
+            <a:solidFill>
+              <a:srgbClr val="1A252C"/>
+            </a:solidFill>
+          </a:ln>
+        </p:spPr>
+        <p:style>
+          <a:lnRef idx="1">
+            <a:schemeClr val="accent1"/>
+          </a:lnRef>
+          <a:fillRef idx="3">
+            <a:schemeClr val="accent1"/>
+          </a:fillRef>
+          <a:effectRef idx="2">
+            <a:schemeClr val="accent1"/>
+          </a:effectRef>
+          <a:fontRef idx="minor">
+            <a:schemeClr val="lt1"/>
+          </a:fontRef>
+        </p:style>
+        <p:txBody>
+          <a:bodyPr rtlCol="0" anchor="ctr" wrap="square" tIns="36576" bIns="36576" lIns="36576" rIns="36576"/>
+          <a:lstStyle/>
+          <a:p>
+            <a:pPr algn="ctr">
+              <a:defRPr sz="850" b="1">
+                <a:solidFill>
+                  <a:srgbClr val="FFFFFF"/>
+                </a:solidFill>
+              </a:defRPr>
+            </a:pPr>
+            <a:r>
+              <a:t>Add [F(x) + x]</a:t>
+            </a:r>
+            <a:br/>
+            <a:r>
+              <a:t>+ ReLU (128,32,16)</a:t>
+            </a:r>
+          </a:p>
+        </p:txBody>
+      </p:sp>
+      <p:sp>
+        <p:nvSpPr>
+          <p:cNvPr id="29" name="Rounded Rectangle 28"/>
+          <p:cNvSpPr/>
+          <p:nvPr/>
+        </p:nvSpPr>
+        <p:spPr>
+          <a:xfrm>
+            <a:off x="9692640" y="2926080"/>
+            <a:ext cx="1005840" cy="1188720"/>
+          </a:xfrm>
+          <a:prstGeom prst="roundRect">
+            <a:avLst/>
+          </a:prstGeom>
+          <a:solidFill>
+            <a:srgbClr val="00838F"/>
+          </a:solidFill>
+          <a:ln w="15240">
+            <a:solidFill>
+              <a:srgbClr val="1A252C"/>
+            </a:solidFill>
+          </a:ln>
+        </p:spPr>
+        <p:style>
+          <a:lnRef idx="1">
+            <a:schemeClr val="accent1"/>
+          </a:lnRef>
+          <a:fillRef idx="3">
+            <a:schemeClr val="accent1"/>
+          </a:fillRef>
+          <a:effectRef idx="2">
+            <a:schemeClr val="accent1"/>
+          </a:effectRef>
+          <a:fontRef idx="minor">
+            <a:schemeClr val="lt1"/>
+          </a:fontRef>
+        </p:style>
+        <p:txBody>
+          <a:bodyPr rtlCol="0" anchor="ctr" wrap="square" tIns="36576" bIns="36576" lIns="36576" rIns="36576"/>
+          <a:lstStyle/>
+          <a:p>
+            <a:pPr algn="ctr">
+              <a:defRPr sz="850" b="1">
+                <a:solidFill>
+                  <a:srgbClr val="FFFFFF"/>
+                </a:solidFill>
+              </a:defRPr>
+            </a:pPr>
+            <a:r>
+              <a:t>Global Avg Pool</a:t>
+            </a:r>
+            <a:br/>
+            <a:r>
+              <a:t>AdaptivePool</a:t>
+            </a:r>
+            <a:br/>
+            <a:r>
+              <a:t>(128-d)</a:t>
+            </a:r>
+          </a:p>
+        </p:txBody>
+      </p:sp>
+      <p:sp>
+        <p:nvSpPr>
+          <p:cNvPr id="30" name="Rounded Rectangle 29"/>
+          <p:cNvSpPr/>
+          <p:nvPr/>
+        </p:nvSpPr>
+        <p:spPr>
+          <a:xfrm>
+            <a:off x="10881360" y="1645920"/>
+            <a:ext cx="1005840" cy="914400"/>
+          </a:xfrm>
+          <a:prstGeom prst="roundRect">
+            <a:avLst/>
+          </a:prstGeom>
+          <a:solidFill>
+            <a:srgbClr val="0D233A"/>
+          </a:solidFill>
+          <a:ln w="15240">
+            <a:solidFill>
+              <a:srgbClr val="1A252C"/>
+            </a:solidFill>
+          </a:ln>
+        </p:spPr>
+        <p:style>
+          <a:lnRef idx="1">
+            <a:schemeClr val="accent1"/>
+          </a:lnRef>
+          <a:fillRef idx="3">
+            <a:schemeClr val="accent1"/>
+          </a:fillRef>
+          <a:effectRef idx="2">
+            <a:schemeClr val="accent1"/>
+          </a:effectRef>
+          <a:fontRef idx="minor">
+            <a:schemeClr val="lt1"/>
+          </a:fontRef>
+        </p:style>
+        <p:txBody>
+          <a:bodyPr rtlCol="0" anchor="ctr" wrap="square" tIns="36576" bIns="36576" lIns="36576" rIns="36576"/>
+          <a:lstStyle/>
+          <a:p>
+            <a:pPr algn="ctr">
+              <a:defRPr sz="850" b="1">
+                <a:solidFill>
+                  <a:srgbClr val="FFFFFF"/>
+                </a:solidFill>
+              </a:defRPr>
+            </a:pPr>
+            <a:r>
+              <a:t>Dropout</a:t>
+            </a:r>
+            <a:br/>
+            <a:r>
+              <a:t>(p = 0.15)</a:t>
+            </a:r>
+          </a:p>
+        </p:txBody>
+      </p:sp>
+      <p:sp>
+        <p:nvSpPr>
+          <p:cNvPr id="31" name="Rounded Rectangle 30"/>
+          <p:cNvSpPr/>
+          <p:nvPr/>
+        </p:nvSpPr>
+        <p:spPr>
+          <a:xfrm>
+            <a:off x="10881360" y="3017520"/>
+            <a:ext cx="1005840" cy="1005840"/>
+          </a:xfrm>
+          <a:prstGeom prst="roundRect">
+            <a:avLst/>
+          </a:prstGeom>
+          <a:solidFill>
+            <a:srgbClr val="6A1B9A"/>
+          </a:solidFill>
+          <a:ln w="15240">
+            <a:solidFill>
+              <a:srgbClr val="1A252C"/>
+            </a:solidFill>
+          </a:ln>
+        </p:spPr>
+        <p:style>
+          <a:lnRef idx="1">
+            <a:schemeClr val="accent1"/>
+          </a:lnRef>
+          <a:fillRef idx="3">
+            <a:schemeClr val="accent1"/>
+          </a:fillRef>
+          <a:effectRef idx="2">
+            <a:schemeClr val="accent1"/>
+          </a:effectRef>
+          <a:fontRef idx="minor">
+            <a:schemeClr val="lt1"/>
+          </a:fontRef>
+        </p:style>
+        <p:txBody>
+          <a:bodyPr rtlCol="0" anchor="ctr" wrap="square" tIns="36576" bIns="36576" lIns="36576" rIns="36576"/>
+          <a:lstStyle/>
+          <a:p>
+            <a:pPr algn="ctr">
+              <a:defRPr sz="850" b="1">
+                <a:solidFill>
+                  <a:srgbClr val="FFFFFF"/>
+                </a:solidFill>
+              </a:defRPr>
+            </a:pPr>
+            <a:r>
+              <a:t>Dense FC</a:t>
+            </a:r>
+            <a:br/>
+            <a:r>
+              <a:t>Linear(128→7)</a:t>
+            </a:r>
+            <a:br/>
+            <a:r>
+              <a:t>+ Softmax</a:t>
+            </a:r>
+          </a:p>
+        </p:txBody>
+      </p:sp>
+      <p:sp>
+        <p:nvSpPr>
+          <p:cNvPr id="32" name="Rounded Rectangle 31"/>
+          <p:cNvSpPr/>
+          <p:nvPr/>
+        </p:nvSpPr>
+        <p:spPr>
+          <a:xfrm>
+            <a:off x="10881360" y="4480560"/>
+            <a:ext cx="1005840" cy="1005840"/>
+          </a:xfrm>
+          <a:prstGeom prst="roundRect">
+            <a:avLst/>
+          </a:prstGeom>
+          <a:solidFill>
+            <a:srgbClr val="F5A623"/>
+          </a:solidFill>
+          <a:ln w="15240">
+            <a:solidFill>
+              <a:srgbClr val="1A252C"/>
+            </a:solidFill>
+          </a:ln>
+        </p:spPr>
+        <p:style>
+          <a:lnRef idx="1">
+            <a:schemeClr val="accent1"/>
+          </a:lnRef>
+          <a:fillRef idx="3">
+            <a:schemeClr val="accent1"/>
+          </a:fillRef>
+          <a:effectRef idx="2">
+            <a:schemeClr val="accent1"/>
+          </a:effectRef>
+          <a:fontRef idx="minor">
+            <a:schemeClr val="lt1"/>
+          </a:fontRef>
+        </p:style>
+        <p:txBody>
+          <a:bodyPr rtlCol="0" anchor="ctr" wrap="square" tIns="36576" bIns="36576" lIns="36576" rIns="36576"/>
+          <a:lstStyle/>
+          <a:p>
+            <a:pPr algn="ctr">
+              <a:defRPr sz="850" b="1">
+                <a:solidFill>
+                  <a:srgbClr val="000000"/>
+                </a:solidFill>
+              </a:defRPr>
+            </a:pPr>
+            <a:r>
+              <a:t>Output</a:t>
+            </a:r>
+            <a:br/>
+            <a:r>
+              <a:t>(7 Command</a:t>
+            </a:r>
+            <a:br/>
+            <a:r>
+              <a:t>Classes)</a:t>
+            </a:r>
+          </a:p>
+        </p:txBody>
+      </p:sp>
+      <p:sp>
+        <p:nvSpPr>
+          <p:cNvPr id="33" name="TextBox 32"/>
           <p:cNvSpPr txBox="1"/>
           <p:nvPr/>
         </p:nvSpPr>
         <p:spPr>
           <a:xfrm>
-            <a:off x="731520" y="5760720"/>
-            <a:ext cx="10728655" cy="640080"/>
+            <a:off x="548640" y="5943600"/>
+            <a:ext cx="11094415" cy="457200"/>
           </a:xfrm>
           <a:prstGeom prst="rect">
             <a:avLst/>
@@ -4378,7 +4858,7 @@
               </a:defRPr>
             </a:pPr>
             <a:r>
-              <a:t>Editable PowerPoint Elements: All blocks, labels, and tensor shapes can be directly moved, restyled, or edited in Microsoft PowerPoint.</a:t>
+              <a:t>Native PowerPoint Shapes: All blocks, labels, and text can be freely selected, moved, colored, or edited directly in PowerPoint.</a:t>
             </a:r>
           </a:p>
         </p:txBody>
@@ -4409,8 +4889,8 @@
         </p:nvSpPr>
         <p:spPr>
           <a:xfrm>
-            <a:off x="731520" y="365760"/>
-            <a:ext cx="10728655" cy="731520"/>
+            <a:off x="548640" y="320040"/>
+            <a:ext cx="11094415" cy="822960"/>
           </a:xfrm>
           <a:prstGeom prst="rect">
             <a:avLst/>
@@ -4431,12 +4911,12 @@
               </a:defRPr>
             </a:pPr>
             <a:r>
-              <a:t>Figure: Detailed Architecture of Broadcasted Residual Block (BC-ResBlock)</a:t>
+              <a:t>Detailed Architecture of Broadcasted Residual Block (BC-ResBlock)</a:t>
             </a:r>
           </a:p>
           <a:p>
             <a:pPr>
-              <a:defRPr sz="1200">
+              <a:defRPr sz="1100">
                 <a:solidFill>
                   <a:srgbClr val="475569"/>
                 </a:solidFill>
@@ -4456,16 +4936,16 @@
         </p:nvSpPr>
         <p:spPr>
           <a:xfrm>
-            <a:off x="731520" y="2926080"/>
-            <a:ext cx="1645920" cy="1097280"/>
+            <a:off x="548640" y="2286000"/>
+            <a:ext cx="1371600" cy="1097280"/>
           </a:xfrm>
           <a:prstGeom prst="roundRect">
             <a:avLst/>
           </a:prstGeom>
           <a:solidFill>
-            <a:srgbClr val="F5A623"/>
-          </a:solidFill>
-          <a:ln>
+            <a:srgbClr val="4A90E2"/>
+          </a:solidFill>
+          <a:ln w="15240">
             <a:solidFill>
               <a:srgbClr val="1A252C"/>
             </a:solidFill>
@@ -4486,13 +4966,13 @@
           </a:fontRef>
         </p:style>
         <p:txBody>
-          <a:bodyPr rtlCol="0" anchor="ctr" wrap="square"/>
+          <a:bodyPr rtlCol="0" anchor="ctr" wrap="square" tIns="36576" bIns="36576" lIns="36576" rIns="36576"/>
           <a:lstStyle/>
           <a:p>
             <a:pPr algn="ctr">
-              <a:defRPr b="1" sz="1100">
-                <a:solidFill>
-                  <a:srgbClr val="000000"/>
+              <a:defRPr sz="950" b="1">
+                <a:solidFill>
+                  <a:srgbClr val="FFFFFF"/>
                 </a:solidFill>
               </a:defRPr>
             </a:pPr>
@@ -4501,7 +4981,7 @@
             </a:r>
             <a:br/>
             <a:r>
-              <a:t>X ∈ R^(C × F × T)</a:t>
+              <a:t>X ∈ R^(C×F×T)</a:t>
             </a:r>
           </a:p>
         </p:txBody>
@@ -4514,8 +4994,8 @@
         </p:nvSpPr>
         <p:spPr>
           <a:xfrm>
-            <a:off x="3108960" y="1645920"/>
-            <a:ext cx="2011680" cy="1280160"/>
+            <a:off x="2194560" y="2286000"/>
+            <a:ext cx="1371600" cy="1097280"/>
           </a:xfrm>
           <a:prstGeom prst="roundRect">
             <a:avLst/>
@@ -4523,7 +5003,7 @@
           <a:solidFill>
             <a:srgbClr val="4A90E2"/>
           </a:solidFill>
-          <a:ln>
+          <a:ln w="15240">
             <a:solidFill>
               <a:srgbClr val="1A252C"/>
             </a:solidFill>
@@ -4544,11 +5024,11 @@
           </a:fontRef>
         </p:style>
         <p:txBody>
-          <a:bodyPr rtlCol="0" anchor="ctr" wrap="square"/>
+          <a:bodyPr rtlCol="0" anchor="ctr" wrap="square" tIns="36576" bIns="36576" lIns="36576" rIns="36576"/>
           <a:lstStyle/>
           <a:p>
             <a:pPr algn="ctr">
-              <a:defRPr b="1" sz="1000">
+              <a:defRPr sz="900" b="1">
                 <a:solidFill>
                   <a:srgbClr val="FFFFFF"/>
                 </a:solidFill>
@@ -4559,7 +5039,7 @@
             </a:r>
             <a:br/>
             <a:r>
-              <a:t>3 × 1 Kernel (Groups=C)</a:t>
+              <a:t>3×1 (Groups=C)</a:t>
             </a:r>
             <a:br/>
             <a:r>
@@ -4576,8 +5056,8 @@
         </p:nvSpPr>
         <p:spPr>
           <a:xfrm>
-            <a:off x="5669280" y="1645920"/>
-            <a:ext cx="1920240" cy="1280160"/>
+            <a:off x="3840480" y="2286000"/>
+            <a:ext cx="1371600" cy="1097280"/>
           </a:xfrm>
           <a:prstGeom prst="roundRect">
             <a:avLst/>
@@ -4585,7 +5065,7 @@
           <a:solidFill>
             <a:srgbClr val="4A90E2"/>
           </a:solidFill>
-          <a:ln>
+          <a:ln w="15240">
             <a:solidFill>
               <a:srgbClr val="1A252C"/>
             </a:solidFill>
@@ -4606,11 +5086,11 @@
           </a:fontRef>
         </p:style>
         <p:txBody>
-          <a:bodyPr rtlCol="0" anchor="ctr" wrap="square"/>
+          <a:bodyPr rtlCol="0" anchor="ctr" wrap="square" tIns="36576" bIns="36576" lIns="36576" rIns="36576"/>
           <a:lstStyle/>
           <a:p>
             <a:pPr algn="ctr">
-              <a:defRPr b="1" sz="1000">
+              <a:defRPr sz="900" b="1">
                 <a:solidFill>
                   <a:srgbClr val="FFFFFF"/>
                 </a:solidFill>
@@ -4621,7 +5101,7 @@
             </a:r>
             <a:br/>
             <a:r>
-              <a:t>1 × 1 Conv (C → C')</a:t>
+              <a:t>1×1 (C → C')</a:t>
             </a:r>
             <a:br/>
             <a:r>
@@ -4638,8 +5118,8 @@
         </p:nvSpPr>
         <p:spPr>
           <a:xfrm>
-            <a:off x="3108960" y="3474720"/>
-            <a:ext cx="4480560" cy="1463040"/>
+            <a:off x="5486400" y="1645920"/>
+            <a:ext cx="4480560" cy="2377440"/>
           </a:xfrm>
           <a:prstGeom prst="roundRect">
             <a:avLst/>
@@ -4683,18 +5163,18 @@
         </p:nvSpPr>
         <p:spPr>
           <a:xfrm>
-            <a:off x="3291840" y="3749039"/>
-            <a:ext cx="4114800" cy="1005840"/>
+            <a:off x="5577840" y="1499616"/>
+            <a:ext cx="4297680" cy="292608"/>
           </a:xfrm>
           <a:prstGeom prst="roundRect">
             <a:avLst/>
           </a:prstGeom>
           <a:solidFill>
-            <a:srgbClr val="00838F"/>
-          </a:solidFill>
-          <a:ln>
+            <a:srgbClr val="FFE0B2"/>
+          </a:solidFill>
+          <a:ln w="12700">
             <a:solidFill>
-              <a:srgbClr val="1A252C"/>
+              <a:srgbClr val="E65100"/>
             </a:solidFill>
           </a:ln>
         </p:spPr>
@@ -4713,48 +5193,40 @@
           </a:fontRef>
         </p:style>
         <p:txBody>
-          <a:bodyPr rtlCol="0" anchor="ctr" wrap="square"/>
+          <a:bodyPr rtlCol="0" anchor="ctr"/>
           <a:lstStyle/>
           <a:p>
             <a:pPr algn="ctr">
-              <a:defRPr b="1" sz="950">
-                <a:solidFill>
-                  <a:srgbClr val="FFFFFF"/>
+              <a:defRPr sz="850" b="1">
+                <a:solidFill>
+                  <a:srgbClr val="BF360C"/>
                 </a:solidFill>
               </a:defRPr>
             </a:pPr>
             <a:r>
-              <a:t>Broadcast Frequency Attention (BFA)</a:t>
-            </a:r>
-            <a:br/>
-            <a:r>
-              <a:t>AvgPool across Frequency (dim=2) → 1×1 Conv + BN + Sigmoid</a:t>
-            </a:r>
-            <a:br/>
-            <a:r>
-              <a:t>Output: [C', 1, T] → Broadcasted across F</a:t>
-            </a:r>
-          </a:p>
-        </p:txBody>
-      </p:sp>
-      <p:sp>
-        <p:nvSpPr>
-          <p:cNvPr id="8" name="Oval 7"/>
+              <a:t>Broadcasted Frequency Attention (BFA) Operator</a:t>
+            </a:r>
+          </a:p>
+        </p:txBody>
+      </p:sp>
+      <p:sp>
+        <p:nvSpPr>
+          <p:cNvPr id="8" name="Rounded Rectangle 7"/>
           <p:cNvSpPr/>
           <p:nvPr/>
         </p:nvSpPr>
         <p:spPr>
           <a:xfrm>
-            <a:off x="8229600" y="2011680"/>
-            <a:ext cx="594360" cy="594360"/>
-          </a:xfrm>
-          <a:prstGeom prst="ellipse">
+            <a:off x="5669280" y="2286000"/>
+            <a:ext cx="1280160" cy="1097280"/>
+          </a:xfrm>
+          <a:prstGeom prst="roundRect">
             <a:avLst/>
           </a:prstGeom>
           <a:solidFill>
-            <a:srgbClr val="F5A623"/>
-          </a:solidFill>
-          <a:ln>
+            <a:srgbClr val="00838F"/>
+          </a:solidFill>
+          <a:ln w="15240">
             <a:solidFill>
               <a:srgbClr val="1A252C"/>
             </a:solidFill>
@@ -4775,14 +5247,26 @@
           </a:fontRef>
         </p:style>
         <p:txBody>
-          <a:bodyPr rtlCol="0" anchor="ctr"/>
+          <a:bodyPr rtlCol="0" anchor="ctr" wrap="square" tIns="36576" bIns="36576" lIns="36576" rIns="36576"/>
           <a:lstStyle/>
           <a:p>
             <a:pPr algn="ctr">
-              <a:defRPr b="1" sz="1600"/>
+              <a:defRPr sz="850" b="1">
+                <a:solidFill>
+                  <a:srgbClr val="FFFFFF"/>
+                </a:solidFill>
+              </a:defRPr>
             </a:pPr>
             <a:r>
-              <a:t>⊗</a:t>
+              <a:t>Freq AvgPool (F_avg)</a:t>
+            </a:r>
+            <a:br/>
+            <a:r>
+              <a:t>z = (1/F) Σ_f x(f)</a:t>
+            </a:r>
+            <a:br/>
+            <a:r>
+              <a:t>z ∈ R^(C'×1×T)</a:t>
             </a:r>
           </a:p>
         </p:txBody>
@@ -4795,16 +5279,16 @@
         </p:nvSpPr>
         <p:spPr>
           <a:xfrm>
-            <a:off x="3108960" y="5303520"/>
-            <a:ext cx="4480560" cy="914400"/>
+            <a:off x="7132320" y="2286000"/>
+            <a:ext cx="1280160" cy="1097280"/>
           </a:xfrm>
           <a:prstGeom prst="roundRect">
             <a:avLst/>
           </a:prstGeom>
           <a:solidFill>
-            <a:srgbClr val="64748B"/>
-          </a:solidFill>
-          <a:ln>
+            <a:srgbClr val="6A1B9A"/>
+          </a:solidFill>
+          <a:ln w="15240">
             <a:solidFill>
               <a:srgbClr val="1A252C"/>
             </a:solidFill>
@@ -4825,44 +5309,44 @@
           </a:fontRef>
         </p:style>
         <p:txBody>
-          <a:bodyPr rtlCol="0" anchor="ctr" wrap="square"/>
+          <a:bodyPr rtlCol="0" anchor="ctr" wrap="square" tIns="36576" bIns="36576" lIns="36576" rIns="36576"/>
           <a:lstStyle/>
           <a:p>
             <a:pPr algn="ctr">
-              <a:defRPr b="1" sz="1000">
+              <a:defRPr sz="850" b="1">
                 <a:solidFill>
                   <a:srgbClr val="FFFFFF"/>
                 </a:solidFill>
               </a:defRPr>
             </a:pPr>
             <a:r>
-              <a:t>Residual Shortcut</a:t>
+              <a:t>1×1 Conv + BN</a:t>
             </a:r>
             <a:br/>
             <a:r>
-              <a:t>Identity (s=1, C=C')  or  Conv 1×1 + BN (s&gt;1 or C≠C')</a:t>
-            </a:r>
-          </a:p>
-        </p:txBody>
-      </p:sp>
-      <p:sp>
-        <p:nvSpPr>
-          <p:cNvPr id="10" name="Oval 9"/>
+              <a:t>Channel Mixing</a:t>
+            </a:r>
+          </a:p>
+        </p:txBody>
+      </p:sp>
+      <p:sp>
+        <p:nvSpPr>
+          <p:cNvPr id="10" name="Rounded Rectangle 9"/>
           <p:cNvSpPr/>
           <p:nvPr/>
         </p:nvSpPr>
         <p:spPr>
           <a:xfrm>
-            <a:off x="9418320" y="3200400"/>
-            <a:ext cx="640080" cy="640080"/>
-          </a:xfrm>
-          <a:prstGeom prst="ellipse">
+            <a:off x="8595360" y="2286000"/>
+            <a:ext cx="1188720" cy="1097280"/>
+          </a:xfrm>
+          <a:prstGeom prst="roundRect">
             <a:avLst/>
           </a:prstGeom>
           <a:solidFill>
-            <a:srgbClr val="27AE60"/>
-          </a:solidFill>
-          <a:ln>
+            <a:srgbClr val="6A1B9A"/>
+          </a:solidFill>
+          <a:ln w="15240">
             <a:solidFill>
               <a:srgbClr val="1A252C"/>
             </a:solidFill>
@@ -4883,18 +5367,22 @@
           </a:fontRef>
         </p:style>
         <p:txBody>
-          <a:bodyPr rtlCol="0" anchor="ctr"/>
+          <a:bodyPr rtlCol="0" anchor="ctr" wrap="square" tIns="36576" bIns="36576" lIns="36576" rIns="36576"/>
           <a:lstStyle/>
           <a:p>
             <a:pPr algn="ctr">
-              <a:defRPr b="1" sz="1800">
+              <a:defRPr sz="850" b="1">
                 <a:solidFill>
                   <a:srgbClr val="FFFFFF"/>
                 </a:solidFill>
               </a:defRPr>
             </a:pPr>
             <a:r>
-              <a:t>⊕</a:t>
+              <a:t>Sigmoid (σ)</a:t>
+            </a:r>
+            <a:br/>
+            <a:r>
+              <a:t>s ∈ [0, 1]^(C'×1×T)</a:t>
             </a:r>
           </a:p>
         </p:txBody>
@@ -4907,16 +5395,16 @@
         </p:nvSpPr>
         <p:spPr>
           <a:xfrm>
-            <a:off x="10424160" y="2926080"/>
-            <a:ext cx="1371600" cy="1188720"/>
+            <a:off x="10241280" y="2286000"/>
+            <a:ext cx="731520" cy="1097280"/>
           </a:xfrm>
           <a:prstGeom prst="roundRect">
             <a:avLst/>
           </a:prstGeom>
           <a:solidFill>
-            <a:srgbClr val="6A1B9A"/>
-          </a:solidFill>
-          <a:ln>
+            <a:srgbClr val="D81B60"/>
+          </a:solidFill>
+          <a:ln w="15240">
             <a:solidFill>
               <a:srgbClr val="1A252C"/>
             </a:solidFill>
@@ -4937,49 +5425,47 @@
           </a:fontRef>
         </p:style>
         <p:txBody>
-          <a:bodyPr rtlCol="0" anchor="ctr" wrap="square"/>
+          <a:bodyPr rtlCol="0" anchor="ctr" wrap="square" tIns="36576" bIns="36576" lIns="36576" rIns="36576"/>
           <a:lstStyle/>
           <a:p>
             <a:pPr algn="ctr">
-              <a:defRPr b="1" sz="1050">
+              <a:defRPr sz="850" b="1">
                 <a:solidFill>
                   <a:srgbClr val="FFFFFF"/>
                 </a:solidFill>
               </a:defRPr>
             </a:pPr>
             <a:r>
-              <a:t>Calibrated</a:t>
+              <a:t>Scale ⊗</a:t>
             </a:r>
             <a:br/>
             <a:r>
-              <a:t>Output</a:t>
-            </a:r>
-            <a:br/>
-            <a:r>
-              <a:t>ReLU(Out + Res)</a:t>
-            </a:r>
-          </a:p>
-        </p:txBody>
-      </p:sp>
-      <p:sp>
-        <p:nvSpPr>
-          <p:cNvPr id="12" name="Right Arrow 11"/>
+              <a:t>Broadcast</a:t>
+            </a:r>
+          </a:p>
+        </p:txBody>
+      </p:sp>
+      <p:sp>
+        <p:nvSpPr>
+          <p:cNvPr id="12" name="Rounded Rectangle 11"/>
           <p:cNvSpPr/>
           <p:nvPr/>
         </p:nvSpPr>
         <p:spPr>
           <a:xfrm>
-            <a:off x="2377440" y="2148840"/>
-            <a:ext cx="640080" cy="228600"/>
-          </a:xfrm>
-          <a:prstGeom prst="rightArrow">
+            <a:off x="11155680" y="2286000"/>
+            <a:ext cx="731520" cy="1097280"/>
+          </a:xfrm>
+          <a:prstGeom prst="roundRect">
             <a:avLst/>
           </a:prstGeom>
           <a:solidFill>
-            <a:srgbClr val="1976D2"/>
-          </a:solidFill>
-          <a:ln>
-            <a:noFill/>
+            <a:srgbClr val="F5A623"/>
+          </a:solidFill>
+          <a:ln w="15240">
+            <a:solidFill>
+              <a:srgbClr val="1A252C"/>
+            </a:solidFill>
           </a:ln>
         </p:spPr>
         <p:style>
@@ -4997,32 +5483,47 @@
           </a:fontRef>
         </p:style>
         <p:txBody>
-          <a:bodyPr rtlCol="0" anchor="ctr"/>
-          <a:lstStyle/>
-          <a:p>
-            <a:pPr algn="ctr"/>
-          </a:p>
-        </p:txBody>
-      </p:sp>
-      <p:sp>
-        <p:nvSpPr>
-          <p:cNvPr id="13" name="Right Arrow 12"/>
+          <a:bodyPr rtlCol="0" anchor="ctr" wrap="square" tIns="36576" bIns="36576" lIns="36576" rIns="36576"/>
+          <a:lstStyle/>
+          <a:p>
+            <a:pPr algn="ctr">
+              <a:defRPr sz="850" b="1">
+                <a:solidFill>
+                  <a:srgbClr val="000000"/>
+                </a:solidFill>
+              </a:defRPr>
+            </a:pPr>
+            <a:r>
+              <a:t>Output</a:t>
+            </a:r>
+            <a:br/>
+            <a:r>
+              <a:t>X_tilde</a:t>
+            </a:r>
+          </a:p>
+        </p:txBody>
+      </p:sp>
+      <p:sp>
+        <p:nvSpPr>
+          <p:cNvPr id="13" name="Rounded Rectangle 12"/>
           <p:cNvSpPr/>
           <p:nvPr/>
         </p:nvSpPr>
         <p:spPr>
           <a:xfrm>
-            <a:off x="5120640" y="2148840"/>
-            <a:ext cx="457200" cy="228600"/>
-          </a:xfrm>
-          <a:prstGeom prst="rightArrow">
+            <a:off x="3200400" y="4389120"/>
+            <a:ext cx="5029200" cy="822960"/>
+          </a:xfrm>
+          <a:prstGeom prst="roundRect">
             <a:avLst/>
           </a:prstGeom>
           <a:solidFill>
-            <a:srgbClr val="1976D2"/>
-          </a:solidFill>
-          <a:ln>
-            <a:noFill/>
+            <a:srgbClr val="00838F"/>
+          </a:solidFill>
+          <a:ln w="15240">
+            <a:solidFill>
+              <a:srgbClr val="1A252C"/>
+            </a:solidFill>
           </a:ln>
         </p:spPr>
         <p:style>
@@ -5040,182 +5541,58 @@
           </a:fontRef>
         </p:style>
         <p:txBody>
-          <a:bodyPr rtlCol="0" anchor="ctr"/>
-          <a:lstStyle/>
-          <a:p>
-            <a:pPr algn="ctr"/>
-          </a:p>
-        </p:txBody>
-      </p:sp>
-      <p:sp>
-        <p:nvSpPr>
-          <p:cNvPr id="14" name="Right Arrow 13"/>
-          <p:cNvSpPr/>
+          <a:bodyPr rtlCol="0" anchor="ctr" wrap="square" tIns="36576" bIns="36576" lIns="36576" rIns="36576"/>
+          <a:lstStyle/>
+          <a:p>
+            <a:pPr algn="ctr">
+              <a:defRPr sz="950" b="1">
+                <a:solidFill>
+                  <a:srgbClr val="FFFFFF"/>
+                </a:solidFill>
+              </a:defRPr>
+            </a:pPr>
+            <a:r>
+              <a:t>Residual Shortcut Branch</a:t>
+            </a:r>
+            <a:br/>
+            <a:r>
+              <a:t>Identity (s=1)  or  1×1 Conv + BN (s=2)</a:t>
+            </a:r>
+          </a:p>
+        </p:txBody>
+      </p:sp>
+      <p:sp>
+        <p:nvSpPr>
+          <p:cNvPr id="14" name="TextBox 13"/>
+          <p:cNvSpPr txBox="1"/>
           <p:nvPr/>
         </p:nvSpPr>
         <p:spPr>
           <a:xfrm>
-            <a:off x="7589520" y="2148840"/>
-            <a:ext cx="548640" cy="228600"/>
-          </a:xfrm>
-          <a:prstGeom prst="rightArrow">
+            <a:off x="548640" y="5943600"/>
+            <a:ext cx="11094415" cy="457200"/>
+          </a:xfrm>
+          <a:prstGeom prst="rect">
             <a:avLst/>
           </a:prstGeom>
-          <a:solidFill>
-            <a:srgbClr val="1976D2"/>
-          </a:solidFill>
-          <a:ln>
-            <a:noFill/>
-          </a:ln>
-        </p:spPr>
-        <p:style>
-          <a:lnRef idx="1">
-            <a:schemeClr val="accent1"/>
-          </a:lnRef>
-          <a:fillRef idx="3">
-            <a:schemeClr val="accent1"/>
-          </a:fillRef>
-          <a:effectRef idx="2">
-            <a:schemeClr val="accent1"/>
-          </a:effectRef>
-          <a:fontRef idx="minor">
-            <a:schemeClr val="lt1"/>
-          </a:fontRef>
-        </p:style>
-        <p:txBody>
-          <a:bodyPr rtlCol="0" anchor="ctr"/>
-          <a:lstStyle/>
-          <a:p>
-            <a:pPr algn="ctr"/>
-          </a:p>
-        </p:txBody>
-      </p:sp>
-      <p:sp>
-        <p:nvSpPr>
-          <p:cNvPr id="15" name="Right Arrow 14"/>
-          <p:cNvSpPr/>
-          <p:nvPr/>
-        </p:nvSpPr>
-        <p:spPr>
-          <a:xfrm>
-            <a:off x="8823960" y="2560320"/>
-            <a:ext cx="548640" cy="228600"/>
-          </a:xfrm>
-          <a:prstGeom prst="rightArrow">
-            <a:avLst/>
-          </a:prstGeom>
-          <a:solidFill>
-            <a:srgbClr val="1976D2"/>
-          </a:solidFill>
-          <a:ln>
-            <a:noFill/>
-          </a:ln>
-        </p:spPr>
-        <p:style>
-          <a:lnRef idx="1">
-            <a:schemeClr val="accent1"/>
-          </a:lnRef>
-          <a:fillRef idx="3">
-            <a:schemeClr val="accent1"/>
-          </a:fillRef>
-          <a:effectRef idx="2">
-            <a:schemeClr val="accent1"/>
-          </a:effectRef>
-          <a:fontRef idx="minor">
-            <a:schemeClr val="lt1"/>
-          </a:fontRef>
-        </p:style>
-        <p:txBody>
-          <a:bodyPr rtlCol="0" anchor="ctr"/>
-          <a:lstStyle/>
-          <a:p>
-            <a:pPr algn="ctr"/>
-          </a:p>
-        </p:txBody>
-      </p:sp>
-      <p:sp>
-        <p:nvSpPr>
-          <p:cNvPr id="16" name="Right Arrow 15"/>
-          <p:cNvSpPr/>
-          <p:nvPr/>
-        </p:nvSpPr>
-        <p:spPr>
-          <a:xfrm>
-            <a:off x="7589520" y="5577840"/>
-            <a:ext cx="1737360" cy="228600"/>
-          </a:xfrm>
-          <a:prstGeom prst="rightArrow">
-            <a:avLst/>
-          </a:prstGeom>
-          <a:solidFill>
-            <a:srgbClr val="1976D2"/>
-          </a:solidFill>
-          <a:ln>
-            <a:noFill/>
-          </a:ln>
-        </p:spPr>
-        <p:style>
-          <a:lnRef idx="1">
-            <a:schemeClr val="accent1"/>
-          </a:lnRef>
-          <a:fillRef idx="3">
-            <a:schemeClr val="accent1"/>
-          </a:fillRef>
-          <a:effectRef idx="2">
-            <a:schemeClr val="accent1"/>
-          </a:effectRef>
-          <a:fontRef idx="minor">
-            <a:schemeClr val="lt1"/>
-          </a:fontRef>
-        </p:style>
-        <p:txBody>
-          <a:bodyPr rtlCol="0" anchor="ctr"/>
-          <a:lstStyle/>
-          <a:p>
-            <a:pPr algn="ctr"/>
-          </a:p>
-        </p:txBody>
-      </p:sp>
-      <p:sp>
-        <p:nvSpPr>
-          <p:cNvPr id="17" name="Right Arrow 16"/>
-          <p:cNvSpPr/>
-          <p:nvPr/>
-        </p:nvSpPr>
-        <p:spPr>
-          <a:xfrm>
-            <a:off x="10058400" y="3383280"/>
-            <a:ext cx="320040" cy="228600"/>
-          </a:xfrm>
-          <a:prstGeom prst="rightArrow">
-            <a:avLst/>
-          </a:prstGeom>
-          <a:solidFill>
-            <a:srgbClr val="1976D2"/>
-          </a:solidFill>
-          <a:ln>
-            <a:noFill/>
-          </a:ln>
-        </p:spPr>
-        <p:style>
-          <a:lnRef idx="1">
-            <a:schemeClr val="accent1"/>
-          </a:lnRef>
-          <a:fillRef idx="3">
-            <a:schemeClr val="accent1"/>
-          </a:fillRef>
-          <a:effectRef idx="2">
-            <a:schemeClr val="accent1"/>
-          </a:effectRef>
-          <a:fontRef idx="minor">
-            <a:schemeClr val="lt1"/>
-          </a:fontRef>
-        </p:style>
-        <p:txBody>
-          <a:bodyPr rtlCol="0" anchor="ctr"/>
-          <a:lstStyle/>
-          <a:p>
-            <a:pPr algn="ctr"/>
+          <a:noFill/>
+        </p:spPr>
+        <p:txBody>
+          <a:bodyPr wrap="none">
+            <a:spAutoFit/>
+          </a:bodyPr>
+          <a:lstStyle/>
+          <a:p>
+            <a:pPr>
+              <a:defRPr sz="1000" i="1">
+                <a:solidFill>
+                  <a:srgbClr val="64748B"/>
+                </a:solidFill>
+              </a:defRPr>
+            </a:pPr>
+            <a:r>
+              <a:t>All mathematical labels and component boxes are fully editable PowerPoint vectors.</a:t>
+            </a:r>
           </a:p>
         </p:txBody>
       </p:sp>

</xml_diff>